<commit_message>
Add customer PDF fixes, summary PDF, credit items, time tracker, dashboard filters
- Customer PDF: hide LF column for cabinetry, show upgrade quantities
- Summary PDF: new one-page download option on Print & Email page
- Credit/negative line items: allow negative qty, red strikethrough styling
- Time Tracker: inline editing for start/stop/description, debounced saves
- Dashboard: stage filter chips for Under Contract, admin delete on all sections
- Production flow project planning doc
- New assets: favicon, logo
- Updated outreach emails

Co-Authored-By: Claude Opus 4.6 <noreply@anthropic.com>
</commit_message>
<xml_diff>
--- a/Quote_App_Pitch_Deck.pptx
+++ b/Quote_App_Pitch_Deck.pptx
@@ -4,6 +4,9 @@
   <p:sldMasterIdLst>
     <p:sldMasterId id="2147483648" r:id="rId1"/>
   </p:sldMasterIdLst>
+  <p:notesMasterIdLst>
+    <p:notesMasterId r:id="rId13"/>
+  </p:notesMasterIdLst>
   <p:sldIdLst>
     <p:sldId id="256" r:id="rId2"/>
     <p:sldId id="257" r:id="rId3"/>
@@ -17,9 +20,6 @@
     <p:sldId id="265" r:id="rId11"/>
     <p:sldId id="266" r:id="rId12"/>
   </p:sldIdLst>
-  <p:notesMasterIdLst>
-    <p:notesMasterId r:id="rId13"/>
-  </p:notesMasterIdLst>
   <p:sldSz cx="12192000" cy="6858000"/>
   <p:notesSz cx="6858000" cy="12192000"/>
   <p:defaultTextStyle>
@@ -114,6 +114,11 @@
       </a:defRPr>
     </a:lvl9pPr>
   </p:defaultTextStyle>
+  <p:extLst>
+    <p:ext uri="{EFAFB233-063F-42B5-8137-9DF3F51BA10A}">
+      <p15:sldGuideLst xmlns:p15="http://schemas.microsoft.com/office/powerpoint/2012/main"/>
+    </p:ext>
+  </p:extLst>
 </p:presentation>
 </file>
 
@@ -139,234 +144,10 @@
           <a:chExt cx="0" cy="0"/>
         </a:xfrm>
       </p:grpSpPr>
-      <p:sp>
-        <p:nvSpPr>
-          <p:cNvPr id="2" name="Header Placeholder 1"/>
-          <p:cNvSpPr>
-            <a:spLocks noGrp="1"/>
-          </p:cNvSpPr>
-          <p:nvPr>
-            <p:ph type="hdr" sz="quarter"/>
-          </p:nvPr>
-        </p:nvSpPr>
-        <p:spPr>
-          <a:xfrm>
-            <a:off x="0" y="0"/>
-            <a:ext cx="2971800" cy="458788"/>
-          </a:xfrm>
-          <a:prstGeom prst="rect">
-            <a:avLst/>
-          </a:prstGeom>
-        </p:spPr>
-        <p:txBody>
-          <a:bodyPr vert="horz" lIns="91440" tIns="45720" rIns="91440" bIns="45720" rtlCol="0"/>
-          <a:lstStyle>
-            <a:lvl1pPr algn="l">
-              <a:defRPr sz="1200"/>
-            </a:lvl1pPr>
-          </a:lstStyle>
-          <a:p>
-            <a:endParaRPr lang="en-US"/>
-          </a:p>
-        </p:txBody>
-      </p:sp>
-      <p:sp>
-        <p:nvSpPr>
-          <p:cNvPr id="3" name="Date Placeholder 2"/>
-          <p:cNvSpPr>
-            <a:spLocks noGrp="1"/>
-          </p:cNvSpPr>
-          <p:nvPr>
-            <p:ph type="dt" idx="1"/>
-          </p:nvPr>
-        </p:nvSpPr>
-        <p:spPr>
-          <a:xfrm>
-            <a:off x="3884613" y="0"/>
-            <a:ext cx="2971800" cy="458788"/>
-          </a:xfrm>
-          <a:prstGeom prst="rect">
-            <a:avLst/>
-          </a:prstGeom>
-        </p:spPr>
-        <p:txBody>
-          <a:bodyPr vert="horz" lIns="91440" tIns="45720" rIns="91440" bIns="45720" rtlCol="0"/>
-          <a:lstStyle>
-            <a:lvl1pPr algn="r">
-              <a:defRPr sz="1200"/>
-            </a:lvl1pPr>
-          </a:lstStyle>
-          <a:p>
-            <a:fld id="{5282F153-3F37-0F45-9E97-73ACFA13230C}" type="datetimeFigureOut">
-              <a:rPr lang="en-US"/>
-              <a:t>7/23/19</a:t>
-            </a:fld>
-            <a:endParaRPr lang="en-US"/>
-          </a:p>
-        </p:txBody>
-      </p:sp>
-      <p:sp>
-        <p:nvSpPr>
-          <p:cNvPr id="4" name="Slide Image Placeholder 3"/>
-          <p:cNvSpPr>
-            <a:spLocks noGrp="1" noRot="1" noChangeAspect="1"/>
-          </p:cNvSpPr>
-          <p:nvPr>
-            <p:ph type="sldImg" idx="2"/>
-          </p:nvPr>
-        </p:nvSpPr>
-        <p:spPr>
-          <a:xfrm>
-            <a:off x="685800" y="1143000"/>
-            <a:ext cx="5486400" cy="3086100"/>
-          </a:xfrm>
-          <a:prstGeom prst="rect">
-            <a:avLst/>
-          </a:prstGeom>
-          <a:noFill/>
-          <a:ln w="12700">
-            <a:solidFill>
-              <a:prstClr val="black"/>
-            </a:solidFill>
-          </a:ln>
-        </p:spPr>
-        <p:txBody>
-          <a:bodyPr vert="horz" lIns="91440" tIns="45720" rIns="91440" bIns="45720" rtlCol="0" anchor="ctr"/>
-          <a:lstStyle/>
-          <a:p>
-            <a:endParaRPr lang="en-US"/>
-          </a:p>
-        </p:txBody>
-      </p:sp>
-      <p:sp>
-        <p:nvSpPr>
-          <p:cNvPr id="5" name="Notes Placeholder 4"/>
-          <p:cNvSpPr>
-            <a:spLocks noGrp="1"/>
-          </p:cNvSpPr>
-          <p:nvPr>
-            <p:ph type="body" sz="quarter" idx="3"/>
-          </p:nvPr>
-        </p:nvSpPr>
-        <p:spPr>
-          <a:xfrm>
-            <a:off x="685800" y="4400550"/>
-            <a:ext cx="5486400" cy="3600450"/>
-          </a:xfrm>
-          <a:prstGeom prst="rect">
-            <a:avLst/>
-          </a:prstGeom>
-        </p:spPr>
-        <p:txBody>
-          <a:bodyPr vert="horz" lIns="91440" tIns="45720" rIns="91440" bIns="45720" rtlCol="0"/>
-          <a:lstStyle/>
-          <a:p>
-            <a:pPr lvl="0"/>
-            <a:r>
-              <a:rPr lang="en-US"/>
-              <a:t>Click to edit Master text styles</a:t>
-            </a:r>
-          </a:p>
-          <a:p>
-            <a:pPr lvl="1"/>
-            <a:r>
-              <a:rPr lang="en-US"/>
-              <a:t>Second level</a:t>
-            </a:r>
-          </a:p>
-          <a:p>
-            <a:pPr lvl="2"/>
-            <a:r>
-              <a:rPr lang="en-US"/>
-              <a:t>Third level</a:t>
-            </a:r>
-          </a:p>
-          <a:p>
-            <a:pPr lvl="3"/>
-            <a:r>
-              <a:rPr lang="en-US"/>
-              <a:t>Fourth level</a:t>
-            </a:r>
-          </a:p>
-          <a:p>
-            <a:pPr lvl="4"/>
-            <a:r>
-              <a:rPr lang="en-US"/>
-              <a:t>Fifth level</a:t>
-            </a:r>
-          </a:p>
-        </p:txBody>
-      </p:sp>
-      <p:sp>
-        <p:nvSpPr>
-          <p:cNvPr id="6" name="Footer Placeholder 5"/>
-          <p:cNvSpPr>
-            <a:spLocks noGrp="1"/>
-          </p:cNvSpPr>
-          <p:nvPr>
-            <p:ph type="ftr" sz="quarter" idx="4"/>
-          </p:nvPr>
-        </p:nvSpPr>
-        <p:spPr>
-          <a:xfrm>
-            <a:off x="0" y="8685213"/>
-            <a:ext cx="2971800" cy="458787"/>
-          </a:xfrm>
-          <a:prstGeom prst="rect">
-            <a:avLst/>
-          </a:prstGeom>
-        </p:spPr>
-        <p:txBody>
-          <a:bodyPr vert="horz" lIns="91440" tIns="45720" rIns="91440" bIns="45720" rtlCol="0" anchor="b"/>
-          <a:lstStyle>
-            <a:lvl1pPr algn="l">
-              <a:defRPr sz="1200"/>
-            </a:lvl1pPr>
-          </a:lstStyle>
-          <a:p>
-            <a:endParaRPr lang="en-US"/>
-          </a:p>
-        </p:txBody>
-      </p:sp>
-      <p:sp>
-        <p:nvSpPr>
-          <p:cNvPr id="7" name="Slide Number Placeholder 6"/>
-          <p:cNvSpPr>
-            <a:spLocks noGrp="1"/>
-          </p:cNvSpPr>
-          <p:nvPr>
-            <p:ph type="sldNum" sz="quarter" idx="5"/>
-          </p:nvPr>
-        </p:nvSpPr>
-        <p:spPr>
-          <a:xfrm>
-            <a:off x="3884613" y="8685213"/>
-            <a:ext cx="2971800" cy="458787"/>
-          </a:xfrm>
-          <a:prstGeom prst="rect">
-            <a:avLst/>
-          </a:prstGeom>
-        </p:spPr>
-        <p:txBody>
-          <a:bodyPr vert="horz" lIns="91440" tIns="45720" rIns="91440" bIns="45720" rtlCol="0" anchor="b"/>
-          <a:lstStyle>
-            <a:lvl1pPr algn="r">
-              <a:defRPr sz="1200"/>
-            </a:lvl1pPr>
-          </a:lstStyle>
-          <a:p>
-            <a:fld id="{CE5E9CC1-C706-0F49-92D6-E571CC5EEA8F}" type="slidenum">
-              <a:rPr lang="en-US"/>
-              <a:t>‹#›</a:t>
-            </a:fld>
-            <a:endParaRPr lang="en-US"/>
-          </a:p>
-        </p:txBody>
-      </p:sp>
     </p:spTree>
     <p:extLst>
       <p:ext uri="{BB962C8B-B14F-4D97-AF65-F5344CB8AC3E}">
-        <p14:creationId xmlns:p14="http://schemas.microsoft.com/office/powerpoint/2010/main" val="1024086991"/>
+        <p14:creationId xmlns:p14="http://schemas.microsoft.com/office/powerpoint/2010/main" val="309863392"/>
       </p:ext>
     </p:extLst>
   </p:cSld>
@@ -510,10 +291,6 @@
           <a:bodyPr/>
           <a:lstStyle/>
           <a:p>
-            <a:r>
-              <a:rPr lang="en-US" dirty="0"/>
-              <a:t/>
-            </a:r>
             <a:endParaRPr lang="en-US" dirty="0"/>
           </a:p>
         </p:txBody>
@@ -598,10 +375,6 @@
           <a:bodyPr/>
           <a:lstStyle/>
           <a:p>
-            <a:r>
-              <a:rPr lang="en-US" dirty="0"/>
-              <a:t/>
-            </a:r>
             <a:endParaRPr lang="en-US" dirty="0"/>
           </a:p>
         </p:txBody>
@@ -686,10 +459,6 @@
           <a:bodyPr/>
           <a:lstStyle/>
           <a:p>
-            <a:r>
-              <a:rPr lang="en-US" dirty="0"/>
-              <a:t/>
-            </a:r>
             <a:endParaRPr lang="en-US" dirty="0"/>
           </a:p>
         </p:txBody>
@@ -774,10 +543,6 @@
           <a:bodyPr/>
           <a:lstStyle/>
           <a:p>
-            <a:r>
-              <a:rPr lang="en-US" dirty="0"/>
-              <a:t/>
-            </a:r>
             <a:endParaRPr lang="en-US" dirty="0"/>
           </a:p>
         </p:txBody>
@@ -862,10 +627,6 @@
           <a:bodyPr/>
           <a:lstStyle/>
           <a:p>
-            <a:r>
-              <a:rPr lang="en-US" dirty="0"/>
-              <a:t/>
-            </a:r>
             <a:endParaRPr lang="en-US" dirty="0"/>
           </a:p>
         </p:txBody>
@@ -950,10 +711,6 @@
           <a:bodyPr/>
           <a:lstStyle/>
           <a:p>
-            <a:r>
-              <a:rPr lang="en-US" dirty="0"/>
-              <a:t/>
-            </a:r>
             <a:endParaRPr lang="en-US" dirty="0"/>
           </a:p>
         </p:txBody>
@@ -1038,10 +795,6 @@
           <a:bodyPr/>
           <a:lstStyle/>
           <a:p>
-            <a:r>
-              <a:rPr lang="en-US" dirty="0"/>
-              <a:t/>
-            </a:r>
             <a:endParaRPr lang="en-US" dirty="0"/>
           </a:p>
         </p:txBody>
@@ -1126,10 +879,6 @@
           <a:bodyPr/>
           <a:lstStyle/>
           <a:p>
-            <a:r>
-              <a:rPr lang="en-US" dirty="0"/>
-              <a:t/>
-            </a:r>
             <a:endParaRPr lang="en-US" dirty="0"/>
           </a:p>
         </p:txBody>
@@ -1214,10 +963,6 @@
           <a:bodyPr/>
           <a:lstStyle/>
           <a:p>
-            <a:r>
-              <a:rPr lang="en-US" dirty="0"/>
-              <a:t/>
-            </a:r>
             <a:endParaRPr lang="en-US" dirty="0"/>
           </a:p>
         </p:txBody>
@@ -1302,10 +1047,6 @@
           <a:bodyPr/>
           <a:lstStyle/>
           <a:p>
-            <a:r>
-              <a:rPr lang="en-US" dirty="0"/>
-              <a:t/>
-            </a:r>
             <a:endParaRPr lang="en-US" dirty="0"/>
           </a:p>
         </p:txBody>
@@ -1390,10 +1131,6 @@
           <a:bodyPr/>
           <a:lstStyle/>
           <a:p>
-            <a:r>
-              <a:rPr lang="en-US" dirty="0"/>
-              <a:t/>
-            </a:r>
             <a:endParaRPr lang="en-US" dirty="0"/>
           </a:p>
         </p:txBody>
@@ -1467,6 +1204,11 @@
 <file path=ppt/slideMasters/slideMaster1.xml><?xml version="1.0" encoding="utf-8"?>
 <p:sldMaster xmlns:a="http://schemas.openxmlformats.org/drawingml/2006/main" xmlns:r="http://schemas.openxmlformats.org/officeDocument/2006/relationships" xmlns:p="http://schemas.openxmlformats.org/presentationml/2006/main">
   <p:cSld>
+    <p:bg>
+      <p:bgRef idx="1001">
+        <a:schemeClr val="bg1"/>
+      </p:bgRef>
+    </p:bg>
     <p:spTree>
       <p:nvGrpSpPr>
         <p:cNvPr id="1" name=""/>
@@ -1749,6 +1491,7 @@
         <a:solidFill>
           <a:srgbClr val="1F242E"/>
         </a:solidFill>
+        <a:effectLst/>
       </p:bgPr>
     </p:bg>
     <p:spTree>
@@ -1784,6 +1527,13 @@
           </a:solidFill>
           <a:ln/>
         </p:spPr>
+        <p:txBody>
+          <a:bodyPr/>
+          <a:lstStyle/>
+          <a:p>
+            <a:endParaRPr lang="en-US"/>
+          </a:p>
+        </p:txBody>
       </p:sp>
       <p:sp>
         <p:nvSpPr>
@@ -1806,11 +1556,11 @@
           <a:bodyPr wrap="square" rtlCol="0" anchor="ctr"/>
           <a:lstStyle/>
           <a:p>
-            <a:pPr indent="0" marL="0">
-              <a:buNone/>
-            </a:pPr>
-            <a:r>
-              <a:rPr lang="en-US" sz="1000" b="1" spc="600" kern="0" dirty="0">
+            <a:pPr marL="0" indent="0">
+              <a:buNone/>
+            </a:pPr>
+            <a:r>
+              <a:rPr lang="en-US" sz="1000" b="1" kern="0" spc="600" dirty="0">
                 <a:solidFill>
                   <a:srgbClr val="C99E64"/>
                 </a:solidFill>
@@ -1845,7 +1595,7 @@
           <a:bodyPr wrap="square" rtlCol="0" anchor="ctr"/>
           <a:lstStyle/>
           <a:p>
-            <a:pPr indent="0" marL="0">
+            <a:pPr marL="0" indent="0">
               <a:buNone/>
             </a:pPr>
             <a:r>
@@ -1884,7 +1634,7 @@
           <a:bodyPr wrap="square" rtlCol="0" anchor="ctr"/>
           <a:lstStyle/>
           <a:p>
-            <a:pPr indent="0" marL="0">
+            <a:pPr marL="0" indent="0">
               <a:buNone/>
             </a:pPr>
             <a:r>
@@ -1923,7 +1673,7 @@
           <a:bodyPr wrap="square" rtlCol="0" anchor="ctr"/>
           <a:lstStyle/>
           <a:p>
-            <a:pPr indent="0" marL="0">
+            <a:pPr marL="0" indent="0">
               <a:buNone/>
             </a:pPr>
             <a:r>
@@ -1960,6 +1710,13 @@
           </a:solidFill>
           <a:ln/>
         </p:spPr>
+        <p:txBody>
+          <a:bodyPr/>
+          <a:lstStyle/>
+          <a:p>
+            <a:endParaRPr lang="en-US"/>
+          </a:p>
+        </p:txBody>
       </p:sp>
       <p:sp>
         <p:nvSpPr>
@@ -1982,7 +1739,7 @@
           <a:bodyPr wrap="square" rtlCol="0" anchor="ctr"/>
           <a:lstStyle/>
           <a:p>
-            <a:pPr indent="0" marL="0">
+            <a:pPr marL="0" indent="0">
               <a:buNone/>
             </a:pPr>
             <a:r>
@@ -2016,6 +1773,7 @@
         <a:solidFill>
           <a:srgbClr val="F2F1ED"/>
         </a:solidFill>
+        <a:effectLst/>
       </p:bgPr>
     </p:bg>
     <p:spTree>
@@ -2051,6 +1809,13 @@
           </a:solidFill>
           <a:ln/>
         </p:spPr>
+        <p:txBody>
+          <a:bodyPr/>
+          <a:lstStyle/>
+          <a:p>
+            <a:endParaRPr lang="en-US"/>
+          </a:p>
+        </p:txBody>
       </p:sp>
       <p:sp>
         <p:nvSpPr>
@@ -2073,11 +1838,11 @@
           <a:bodyPr wrap="square" rtlCol="0" anchor="ctr"/>
           <a:lstStyle/>
           <a:p>
-            <a:pPr indent="0" marL="0">
-              <a:buNone/>
-            </a:pPr>
-            <a:r>
-              <a:rPr lang="en-US" sz="1100" b="1" spc="600" kern="0" dirty="0">
+            <a:pPr marL="0" indent="0">
+              <a:buNone/>
+            </a:pPr>
+            <a:r>
+              <a:rPr lang="en-US" sz="1100" b="1" kern="0" spc="600" dirty="0">
                 <a:solidFill>
                   <a:srgbClr val="A88147"/>
                 </a:solidFill>
@@ -2112,7 +1877,7 @@
           <a:bodyPr wrap="square" rtlCol="0" anchor="ctr"/>
           <a:lstStyle/>
           <a:p>
-            <a:pPr indent="0" marL="0">
+            <a:pPr marL="0" indent="0">
               <a:buNone/>
             </a:pPr>
             <a:r>
@@ -2154,6 +1919,13 @@
             <a:prstDash val="solid"/>
           </a:ln>
         </p:spPr>
+        <p:txBody>
+          <a:bodyPr/>
+          <a:lstStyle/>
+          <a:p>
+            <a:endParaRPr lang="en-US"/>
+          </a:p>
+        </p:txBody>
       </p:sp>
       <p:sp>
         <p:nvSpPr>
@@ -2174,6 +1946,13 @@
           </a:solidFill>
           <a:ln/>
         </p:spPr>
+        <p:txBody>
+          <a:bodyPr/>
+          <a:lstStyle/>
+          <a:p>
+            <a:endParaRPr lang="en-US"/>
+          </a:p>
+        </p:txBody>
       </p:sp>
       <p:sp>
         <p:nvSpPr>
@@ -2196,11 +1975,11 @@
           <a:bodyPr wrap="square" rtlCol="0" anchor="ctr"/>
           <a:lstStyle/>
           <a:p>
-            <a:pPr indent="0" marL="0">
-              <a:buNone/>
-            </a:pPr>
-            <a:r>
-              <a:rPr lang="en-US" sz="1100" b="1" spc="500" kern="0" dirty="0">
+            <a:pPr marL="0" indent="0">
+              <a:buNone/>
+            </a:pPr>
+            <a:r>
+              <a:rPr lang="en-US" sz="1100" b="1" kern="0" spc="500" dirty="0">
                 <a:solidFill>
                   <a:srgbClr val="A88147"/>
                 </a:solidFill>
@@ -2235,7 +2014,7 @@
           <a:bodyPr wrap="square" rtlCol="0" anchor="ctr"/>
           <a:lstStyle/>
           <a:p>
-            <a:pPr indent="0" marL="0">
+            <a:pPr marL="0" indent="0">
               <a:buNone/>
             </a:pPr>
             <a:r>
@@ -2272,6 +2051,13 @@
           </a:solidFill>
           <a:ln/>
         </p:spPr>
+        <p:txBody>
+          <a:bodyPr/>
+          <a:lstStyle/>
+          <a:p>
+            <a:endParaRPr lang="en-US"/>
+          </a:p>
+        </p:txBody>
       </p:sp>
       <p:sp>
         <p:nvSpPr>
@@ -2294,7 +2080,7 @@
           <a:bodyPr wrap="square" rtlCol="0" anchor="ctr"/>
           <a:lstStyle/>
           <a:p>
-            <a:pPr indent="0" marL="0">
+            <a:pPr marL="0" indent="0">
               <a:buNone/>
             </a:pPr>
             <a:r>
@@ -2331,6 +2117,13 @@
           </a:solidFill>
           <a:ln/>
         </p:spPr>
+        <p:txBody>
+          <a:bodyPr/>
+          <a:lstStyle/>
+          <a:p>
+            <a:endParaRPr lang="en-US"/>
+          </a:p>
+        </p:txBody>
       </p:sp>
       <p:sp>
         <p:nvSpPr>
@@ -2353,7 +2146,7 @@
           <a:bodyPr wrap="square" rtlCol="0" anchor="ctr"/>
           <a:lstStyle/>
           <a:p>
-            <a:pPr indent="0" marL="0">
+            <a:pPr marL="0" indent="0">
               <a:buNone/>
             </a:pPr>
             <a:r>
@@ -2390,6 +2183,13 @@
           </a:solidFill>
           <a:ln/>
         </p:spPr>
+        <p:txBody>
+          <a:bodyPr/>
+          <a:lstStyle/>
+          <a:p>
+            <a:endParaRPr lang="en-US"/>
+          </a:p>
+        </p:txBody>
       </p:sp>
       <p:sp>
         <p:nvSpPr>
@@ -2412,7 +2212,7 @@
           <a:bodyPr wrap="square" rtlCol="0" anchor="ctr"/>
           <a:lstStyle/>
           <a:p>
-            <a:pPr indent="0" marL="0">
+            <a:pPr marL="0" indent="0">
               <a:buNone/>
             </a:pPr>
             <a:r>
@@ -2454,6 +2254,13 @@
             <a:prstDash val="solid"/>
           </a:ln>
         </p:spPr>
+        <p:txBody>
+          <a:bodyPr/>
+          <a:lstStyle/>
+          <a:p>
+            <a:endParaRPr lang="en-US"/>
+          </a:p>
+        </p:txBody>
       </p:sp>
       <p:sp>
         <p:nvSpPr>
@@ -2474,6 +2281,13 @@
           </a:solidFill>
           <a:ln/>
         </p:spPr>
+        <p:txBody>
+          <a:bodyPr/>
+          <a:lstStyle/>
+          <a:p>
+            <a:endParaRPr lang="en-US"/>
+          </a:p>
+        </p:txBody>
       </p:sp>
       <p:sp>
         <p:nvSpPr>
@@ -2496,11 +2310,11 @@
           <a:bodyPr wrap="square" rtlCol="0" anchor="ctr"/>
           <a:lstStyle/>
           <a:p>
-            <a:pPr indent="0" marL="0">
-              <a:buNone/>
-            </a:pPr>
-            <a:r>
-              <a:rPr lang="en-US" sz="1100" b="1" spc="500" kern="0" dirty="0">
+            <a:pPr marL="0" indent="0">
+              <a:buNone/>
+            </a:pPr>
+            <a:r>
+              <a:rPr lang="en-US" sz="1100" b="1" kern="0" spc="500" dirty="0">
                 <a:solidFill>
                   <a:srgbClr val="A88147"/>
                 </a:solidFill>
@@ -2535,7 +2349,7 @@
           <a:bodyPr wrap="square" rtlCol="0" anchor="ctr"/>
           <a:lstStyle/>
           <a:p>
-            <a:pPr indent="0" marL="0">
+            <a:pPr marL="0" indent="0">
               <a:buNone/>
             </a:pPr>
             <a:r>
@@ -2572,6 +2386,13 @@
           </a:solidFill>
           <a:ln/>
         </p:spPr>
+        <p:txBody>
+          <a:bodyPr/>
+          <a:lstStyle/>
+          <a:p>
+            <a:endParaRPr lang="en-US"/>
+          </a:p>
+        </p:txBody>
       </p:sp>
       <p:sp>
         <p:nvSpPr>
@@ -2594,7 +2415,7 @@
           <a:bodyPr wrap="square" rtlCol="0" anchor="ctr"/>
           <a:lstStyle/>
           <a:p>
-            <a:pPr indent="0" marL="0">
+            <a:pPr marL="0" indent="0">
               <a:buNone/>
             </a:pPr>
             <a:r>
@@ -2631,6 +2452,13 @@
           </a:solidFill>
           <a:ln/>
         </p:spPr>
+        <p:txBody>
+          <a:bodyPr/>
+          <a:lstStyle/>
+          <a:p>
+            <a:endParaRPr lang="en-US"/>
+          </a:p>
+        </p:txBody>
       </p:sp>
       <p:sp>
         <p:nvSpPr>
@@ -2653,7 +2481,7 @@
           <a:bodyPr wrap="square" rtlCol="0" anchor="ctr"/>
           <a:lstStyle/>
           <a:p>
-            <a:pPr indent="0" marL="0">
+            <a:pPr marL="0" indent="0">
               <a:buNone/>
             </a:pPr>
             <a:r>
@@ -2690,6 +2518,13 @@
           </a:solidFill>
           <a:ln/>
         </p:spPr>
+        <p:txBody>
+          <a:bodyPr/>
+          <a:lstStyle/>
+          <a:p>
+            <a:endParaRPr lang="en-US"/>
+          </a:p>
+        </p:txBody>
       </p:sp>
       <p:sp>
         <p:nvSpPr>
@@ -2712,7 +2547,7 @@
           <a:bodyPr wrap="square" rtlCol="0" anchor="ctr"/>
           <a:lstStyle/>
           <a:p>
-            <a:pPr indent="0" marL="0">
+            <a:pPr marL="0" indent="0">
               <a:buNone/>
             </a:pPr>
             <a:r>
@@ -2751,7 +2586,7 @@
           <a:bodyPr wrap="square" rtlCol="0" anchor="ctr"/>
           <a:lstStyle/>
           <a:p>
-            <a:pPr algn="ctr" indent="0" marL="0">
+            <a:pPr marL="0" indent="0" algn="ctr">
               <a:buNone/>
             </a:pPr>
             <a:r>
@@ -2790,7 +2625,7 @@
           <a:bodyPr wrap="square" rtlCol="0" anchor="ctr"/>
           <a:lstStyle/>
           <a:p>
-            <a:pPr algn="l" indent="0" marL="0">
+            <a:pPr marL="0" indent="0" algn="l">
               <a:buNone/>
             </a:pPr>
             <a:r>
@@ -2829,7 +2664,7 @@
           <a:bodyPr wrap="square" rtlCol="0" anchor="ctr"/>
           <a:lstStyle/>
           <a:p>
-            <a:pPr algn="r" indent="0" marL="0">
+            <a:pPr marL="0" indent="0" algn="r">
               <a:buNone/>
             </a:pPr>
             <a:r>
@@ -2863,6 +2698,7 @@
         <a:solidFill>
           <a:srgbClr val="1F242E"/>
         </a:solidFill>
+        <a:effectLst/>
       </p:bgPr>
     </p:bg>
     <p:spTree>
@@ -2898,6 +2734,13 @@
           </a:solidFill>
           <a:ln/>
         </p:spPr>
+        <p:txBody>
+          <a:bodyPr/>
+          <a:lstStyle/>
+          <a:p>
+            <a:endParaRPr lang="en-US"/>
+          </a:p>
+        </p:txBody>
       </p:sp>
       <p:sp>
         <p:nvSpPr>
@@ -2920,11 +2763,11 @@
           <a:bodyPr wrap="square" rtlCol="0" anchor="ctr"/>
           <a:lstStyle/>
           <a:p>
-            <a:pPr indent="0" marL="0">
-              <a:buNone/>
-            </a:pPr>
-            <a:r>
-              <a:rPr lang="en-US" sz="1100" b="1" spc="600" kern="0" dirty="0">
+            <a:pPr marL="0" indent="0">
+              <a:buNone/>
+            </a:pPr>
+            <a:r>
+              <a:rPr lang="en-US" sz="1100" b="1" kern="0" spc="600" dirty="0">
                 <a:solidFill>
                   <a:srgbClr val="C99E64"/>
                 </a:solidFill>
@@ -2959,7 +2802,7 @@
           <a:bodyPr wrap="square" rtlCol="0" anchor="ctr"/>
           <a:lstStyle/>
           <a:p>
-            <a:pPr indent="0" marL="0">
+            <a:pPr marL="0" indent="0">
               <a:buNone/>
             </a:pPr>
             <a:r>
@@ -2998,7 +2841,7 @@
           <a:bodyPr wrap="square" rtlCol="0" anchor="ctr"/>
           <a:lstStyle/>
           <a:p>
-            <a:pPr indent="0" marL="0">
+            <a:pPr marL="0" indent="0">
               <a:buNone/>
             </a:pPr>
             <a:r>
@@ -3037,7 +2880,7 @@
           <a:bodyPr wrap="square" rtlCol="0" anchor="ctr"/>
           <a:lstStyle/>
           <a:p>
-            <a:pPr indent="0" marL="0">
+            <a:pPr marL="0" indent="0">
               <a:buNone/>
             </a:pPr>
             <a:r>
@@ -3074,6 +2917,13 @@
           </a:solidFill>
           <a:ln/>
         </p:spPr>
+        <p:txBody>
+          <a:bodyPr/>
+          <a:lstStyle/>
+          <a:p>
+            <a:endParaRPr lang="en-US"/>
+          </a:p>
+        </p:txBody>
       </p:sp>
       <p:sp>
         <p:nvSpPr>
@@ -3094,6 +2944,13 @@
           </a:solidFill>
           <a:ln/>
         </p:spPr>
+        <p:txBody>
+          <a:bodyPr/>
+          <a:lstStyle/>
+          <a:p>
+            <a:endParaRPr lang="en-US"/>
+          </a:p>
+        </p:txBody>
       </p:sp>
       <p:sp>
         <p:nvSpPr>
@@ -3116,7 +2973,7 @@
           <a:bodyPr wrap="square" rtlCol="0" anchor="ctr"/>
           <a:lstStyle/>
           <a:p>
-            <a:pPr indent="0" marL="0">
+            <a:pPr marL="0" indent="0">
               <a:buNone/>
             </a:pPr>
             <a:r>
@@ -3128,7 +2985,7 @@
                 <a:ea typeface="Calibri" pitchFamily="34" charset="-122"/>
                 <a:cs typeface="Calibri" pitchFamily="34" charset="-120"/>
               </a:rPr>
-              <a:t>Reply to my email, or grab 30 minutes on my calendar — link below.</a:t>
+              <a:t>Reply to my email or contact on WhatsApp.</a:t>
             </a:r>
             <a:endParaRPr lang="en-US" sz="1400" dirty="0"/>
           </a:p>
@@ -3155,7 +3012,7 @@
           <a:bodyPr wrap="square" rtlCol="0" anchor="ctr"/>
           <a:lstStyle/>
           <a:p>
-            <a:pPr indent="0" marL="0">
+            <a:pPr marL="0" indent="0">
               <a:buNone/>
             </a:pPr>
             <a:r>
@@ -3167,46 +3024,7 @@
                 <a:ea typeface="Calibri" pitchFamily="34" charset="-122"/>
                 <a:cs typeface="Calibri" pitchFamily="34" charset="-120"/>
               </a:rPr>
-              <a:t>[ Your Name ]   ·   [ your.email@domain.com ]   ·   [ (xxx) xxx-xxxx ]</a:t>
-            </a:r>
-            <a:endParaRPr lang="en-US" sz="1300" dirty="0"/>
-          </a:p>
-        </p:txBody>
-      </p:sp>
-      <p:sp>
-        <p:nvSpPr>
-          <p:cNvPr id="11" name="Text 9"/>
-          <p:cNvSpPr/>
-          <p:nvPr/>
-        </p:nvSpPr>
-        <p:spPr>
-          <a:xfrm>
-            <a:off x="914400" y="5806440"/>
-            <a:ext cx="10058400" cy="365760"/>
-          </a:xfrm>
-          <a:prstGeom prst="rect">
-            <a:avLst/>
-          </a:prstGeom>
-          <a:noFill/>
-          <a:ln/>
-        </p:spPr>
-        <p:txBody>
-          <a:bodyPr wrap="square" rtlCol="0" anchor="ctr"/>
-          <a:lstStyle/>
-          <a:p>
-            <a:pPr indent="0" marL="0">
-              <a:buNone/>
-            </a:pPr>
-            <a:r>
-              <a:rPr lang="en-US" sz="1300" i="1" dirty="0">
-                <a:solidFill>
-                  <a:srgbClr val="6E7480"/>
-                </a:solidFill>
-                <a:latin typeface="Calibri" pitchFamily="34" charset="0"/>
-                <a:ea typeface="Calibri" pitchFamily="34" charset="-122"/>
-                <a:cs typeface="Calibri" pitchFamily="34" charset="-120"/>
-              </a:rPr>
-              <a:t>[ calendar link goes here — e.g. cal.com/yourname ]</a:t>
+              <a:t>[ Bilal Ahmed]   ·   [11bilalahmed@gmail.com]   ·   [ +92-321-2665520]</a:t>
             </a:r>
             <a:endParaRPr lang="en-US" sz="1300" dirty="0"/>
           </a:p>
@@ -3233,7 +3051,7 @@
           <a:bodyPr wrap="square" rtlCol="0" anchor="ctr"/>
           <a:lstStyle/>
           <a:p>
-            <a:pPr algn="r" indent="0" marL="0">
+            <a:pPr marL="0" indent="0" algn="r">
               <a:buNone/>
             </a:pPr>
             <a:r>
@@ -3267,6 +3085,7 @@
         <a:solidFill>
           <a:srgbClr val="F2F1ED"/>
         </a:solidFill>
+        <a:effectLst/>
       </p:bgPr>
     </p:bg>
     <p:spTree>
@@ -3302,6 +3121,13 @@
           </a:solidFill>
           <a:ln/>
         </p:spPr>
+        <p:txBody>
+          <a:bodyPr/>
+          <a:lstStyle/>
+          <a:p>
+            <a:endParaRPr lang="en-US"/>
+          </a:p>
+        </p:txBody>
       </p:sp>
       <p:sp>
         <p:nvSpPr>
@@ -3324,11 +3150,11 @@
           <a:bodyPr wrap="square" rtlCol="0" anchor="ctr"/>
           <a:lstStyle/>
           <a:p>
-            <a:pPr indent="0" marL="0">
-              <a:buNone/>
-            </a:pPr>
-            <a:r>
-              <a:rPr lang="en-US" sz="1100" b="1" spc="600" kern="0" dirty="0">
+            <a:pPr marL="0" indent="0">
+              <a:buNone/>
+            </a:pPr>
+            <a:r>
+              <a:rPr lang="en-US" sz="1100" b="1" kern="0" spc="600" dirty="0">
                 <a:solidFill>
                   <a:srgbClr val="A88147"/>
                 </a:solidFill>
@@ -3363,7 +3189,7 @@
           <a:bodyPr wrap="square" rtlCol="0" anchor="ctr"/>
           <a:lstStyle/>
           <a:p>
-            <a:pPr indent="0" marL="0">
+            <a:pPr marL="0" indent="0">
               <a:buNone/>
             </a:pPr>
             <a:r>
@@ -3405,6 +3231,13 @@
             <a:prstDash val="solid"/>
           </a:ln>
         </p:spPr>
+        <p:txBody>
+          <a:bodyPr/>
+          <a:lstStyle/>
+          <a:p>
+            <a:endParaRPr lang="en-US"/>
+          </a:p>
+        </p:txBody>
       </p:sp>
       <p:sp>
         <p:nvSpPr>
@@ -3425,6 +3258,13 @@
           </a:solidFill>
           <a:ln/>
         </p:spPr>
+        <p:txBody>
+          <a:bodyPr/>
+          <a:lstStyle/>
+          <a:p>
+            <a:endParaRPr lang="en-US"/>
+          </a:p>
+        </p:txBody>
       </p:sp>
       <p:sp>
         <p:nvSpPr>
@@ -3447,7 +3287,7 @@
           <a:bodyPr wrap="square" rtlCol="0" anchor="ctr"/>
           <a:lstStyle/>
           <a:p>
-            <a:pPr indent="0" marL="0">
+            <a:pPr marL="0" indent="0">
               <a:buNone/>
             </a:pPr>
             <a:r>
@@ -3486,7 +3326,7 @@
           <a:bodyPr wrap="square" rtlCol="0" anchor="ctr"/>
           <a:lstStyle/>
           <a:p>
-            <a:pPr indent="0" marL="0">
+            <a:pPr marL="0" indent="0">
               <a:buNone/>
             </a:pPr>
             <a:r>
@@ -3525,7 +3365,7 @@
           <a:bodyPr wrap="square" rtlCol="0" anchor="ctr"/>
           <a:lstStyle/>
           <a:p>
-            <a:pPr indent="0" marL="0">
+            <a:pPr marL="0" indent="0">
               <a:spcAft>
                 <a:spcPts val="600"/>
               </a:spcAft>
@@ -3570,6 +3410,13 @@
             <a:prstDash val="solid"/>
           </a:ln>
         </p:spPr>
+        <p:txBody>
+          <a:bodyPr/>
+          <a:lstStyle/>
+          <a:p>
+            <a:endParaRPr lang="en-US"/>
+          </a:p>
+        </p:txBody>
       </p:sp>
       <p:sp>
         <p:nvSpPr>
@@ -3590,6 +3437,13 @@
           </a:solidFill>
           <a:ln/>
         </p:spPr>
+        <p:txBody>
+          <a:bodyPr/>
+          <a:lstStyle/>
+          <a:p>
+            <a:endParaRPr lang="en-US"/>
+          </a:p>
+        </p:txBody>
       </p:sp>
       <p:sp>
         <p:nvSpPr>
@@ -3612,7 +3466,7 @@
           <a:bodyPr wrap="square" rtlCol="0" anchor="ctr"/>
           <a:lstStyle/>
           <a:p>
-            <a:pPr indent="0" marL="0">
+            <a:pPr marL="0" indent="0">
               <a:buNone/>
             </a:pPr>
             <a:r>
@@ -3651,7 +3505,7 @@
           <a:bodyPr wrap="square" rtlCol="0" anchor="ctr"/>
           <a:lstStyle/>
           <a:p>
-            <a:pPr indent="0" marL="0">
+            <a:pPr marL="0" indent="0">
               <a:buNone/>
             </a:pPr>
             <a:r>
@@ -3690,7 +3544,7 @@
           <a:bodyPr wrap="square" rtlCol="0" anchor="ctr"/>
           <a:lstStyle/>
           <a:p>
-            <a:pPr indent="0" marL="0">
+            <a:pPr marL="0" indent="0">
               <a:spcAft>
                 <a:spcPts val="600"/>
               </a:spcAft>
@@ -3735,6 +3589,13 @@
             <a:prstDash val="solid"/>
           </a:ln>
         </p:spPr>
+        <p:txBody>
+          <a:bodyPr/>
+          <a:lstStyle/>
+          <a:p>
+            <a:endParaRPr lang="en-US"/>
+          </a:p>
+        </p:txBody>
       </p:sp>
       <p:sp>
         <p:nvSpPr>
@@ -3755,6 +3616,13 @@
           </a:solidFill>
           <a:ln/>
         </p:spPr>
+        <p:txBody>
+          <a:bodyPr/>
+          <a:lstStyle/>
+          <a:p>
+            <a:endParaRPr lang="en-US"/>
+          </a:p>
+        </p:txBody>
       </p:sp>
       <p:sp>
         <p:nvSpPr>
@@ -3777,7 +3645,7 @@
           <a:bodyPr wrap="square" rtlCol="0" anchor="ctr"/>
           <a:lstStyle/>
           <a:p>
-            <a:pPr indent="0" marL="0">
+            <a:pPr marL="0" indent="0">
               <a:buNone/>
             </a:pPr>
             <a:r>
@@ -3816,7 +3684,7 @@
           <a:bodyPr wrap="square" rtlCol="0" anchor="ctr"/>
           <a:lstStyle/>
           <a:p>
-            <a:pPr indent="0" marL="0">
+            <a:pPr marL="0" indent="0">
               <a:buNone/>
             </a:pPr>
             <a:r>
@@ -3855,7 +3723,7 @@
           <a:bodyPr wrap="square" rtlCol="0" anchor="ctr"/>
           <a:lstStyle/>
           <a:p>
-            <a:pPr indent="0" marL="0">
+            <a:pPr marL="0" indent="0">
               <a:spcAft>
                 <a:spcPts val="600"/>
               </a:spcAft>
@@ -3897,7 +3765,7 @@
           <a:bodyPr wrap="square" rtlCol="0" anchor="ctr"/>
           <a:lstStyle/>
           <a:p>
-            <a:pPr algn="l" indent="0" marL="0">
+            <a:pPr marL="0" indent="0" algn="l">
               <a:buNone/>
             </a:pPr>
             <a:r>
@@ -3936,7 +3804,7 @@
           <a:bodyPr wrap="square" rtlCol="0" anchor="ctr"/>
           <a:lstStyle/>
           <a:p>
-            <a:pPr algn="r" indent="0" marL="0">
+            <a:pPr marL="0" indent="0" algn="r">
               <a:buNone/>
             </a:pPr>
             <a:r>
@@ -3970,6 +3838,7 @@
         <a:solidFill>
           <a:srgbClr val="F2F1ED"/>
         </a:solidFill>
+        <a:effectLst/>
       </p:bgPr>
     </p:bg>
     <p:spTree>
@@ -4005,6 +3874,13 @@
           </a:solidFill>
           <a:ln/>
         </p:spPr>
+        <p:txBody>
+          <a:bodyPr/>
+          <a:lstStyle/>
+          <a:p>
+            <a:endParaRPr lang="en-US"/>
+          </a:p>
+        </p:txBody>
       </p:sp>
       <p:sp>
         <p:nvSpPr>
@@ -4027,11 +3903,11 @@
           <a:bodyPr wrap="square" rtlCol="0" anchor="ctr"/>
           <a:lstStyle/>
           <a:p>
-            <a:pPr indent="0" marL="0">
-              <a:buNone/>
-            </a:pPr>
-            <a:r>
-              <a:rPr lang="en-US" sz="1100" b="1" spc="600" kern="0" dirty="0">
+            <a:pPr marL="0" indent="0">
+              <a:buNone/>
+            </a:pPr>
+            <a:r>
+              <a:rPr lang="en-US" sz="1100" b="1" kern="0" spc="600" dirty="0">
                 <a:solidFill>
                   <a:srgbClr val="A88147"/>
                 </a:solidFill>
@@ -4066,7 +3942,7 @@
           <a:bodyPr wrap="square" rtlCol="0" anchor="ctr"/>
           <a:lstStyle/>
           <a:p>
-            <a:pPr indent="0" marL="0">
+            <a:pPr marL="0" indent="0">
               <a:buNone/>
             </a:pPr>
             <a:r>
@@ -4105,7 +3981,7 @@
           <a:bodyPr wrap="square" rtlCol="0" anchor="ctr"/>
           <a:lstStyle/>
           <a:p>
-            <a:pPr indent="0" marL="0">
+            <a:pPr marL="0" indent="0">
               <a:buNone/>
             </a:pPr>
             <a:r>
@@ -4144,258 +4020,17 @@
             <a:prstDash val="solid"/>
           </a:ln>
         </p:spPr>
+        <p:txBody>
+          <a:bodyPr/>
+          <a:lstStyle/>
+          <a:p>
+            <a:endParaRPr lang="en-US"/>
+          </a:p>
+        </p:txBody>
       </p:sp>
       <p:pic>
         <p:nvPicPr>
-          <p:cNvPr id="7" name="Image 0" descr="C:/Users/SURFACE/Downloads/EWP Quote App/screenshots/01_dashboard.png">    </p:cNvPr>
-          <p:cNvPicPr>
-            <a:picLocks noChangeAspect="1"/>
-          </p:cNvPicPr>
-          <p:nvPr/>
-        </p:nvPicPr>
-        <p:blipFill>
-          <a:blip r:embed="rId1"/>
-          <a:stretch>
-            <a:fillRect/>
-          </a:stretch>
-        </p:blipFill>
-        <p:spPr>
-          <a:xfrm>
-            <a:off x="540868" y="3017520"/>
-            <a:ext cx="3520440" cy="1783080"/>
-          </a:xfrm>
-          <a:prstGeom prst="rect">
-            <a:avLst/>
-          </a:prstGeom>
-        </p:spPr>
-      </p:pic>
-      <p:sp>
-        <p:nvSpPr>
-          <p:cNvPr id="8" name="Text 5"/>
-          <p:cNvSpPr/>
-          <p:nvPr/>
-        </p:nvSpPr>
-        <p:spPr>
-          <a:xfrm>
-            <a:off x="540868" y="4892040"/>
-            <a:ext cx="3520440" cy="365760"/>
-          </a:xfrm>
-          <a:prstGeom prst="rect">
-            <a:avLst/>
-          </a:prstGeom>
-          <a:noFill/>
-          <a:ln/>
-        </p:spPr>
-        <p:txBody>
-          <a:bodyPr wrap="square" rtlCol="0" anchor="ctr"/>
-          <a:lstStyle/>
-          <a:p>
-            <a:pPr algn="ctr" indent="0" marL="0">
-              <a:buNone/>
-            </a:pPr>
-            <a:r>
-              <a:rPr lang="en-US" sz="1800" i="1" dirty="0">
-                <a:solidFill>
-                  <a:srgbClr val="1F242E"/>
-                </a:solidFill>
-                <a:latin typeface="Georgia" pitchFamily="34" charset="0"/>
-                <a:ea typeface="Georgia" pitchFamily="34" charset="-122"/>
-                <a:cs typeface="Georgia" pitchFamily="34" charset="-120"/>
-              </a:rPr>
-              <a:t>Dashboard</a:t>
-            </a:r>
-            <a:endParaRPr lang="en-US" sz="1800" dirty="0"/>
-          </a:p>
-        </p:txBody>
-      </p:sp>
-      <p:sp>
-        <p:nvSpPr>
-          <p:cNvPr id="9" name="Text 6"/>
-          <p:cNvSpPr/>
-          <p:nvPr/>
-        </p:nvSpPr>
-        <p:spPr>
-          <a:xfrm>
-            <a:off x="540868" y="5257800"/>
-            <a:ext cx="3520440" cy="457200"/>
-          </a:xfrm>
-          <a:prstGeom prst="rect">
-            <a:avLst/>
-          </a:prstGeom>
-          <a:noFill/>
-          <a:ln/>
-        </p:spPr>
-        <p:txBody>
-          <a:bodyPr wrap="square" rtlCol="0" anchor="ctr"/>
-          <a:lstStyle/>
-          <a:p>
-            <a:pPr algn="ctr" indent="0" marL="0">
-              <a:buNone/>
-            </a:pPr>
-            <a:r>
-              <a:rPr lang="en-US" sz="1100" dirty="0">
-                <a:solidFill>
-                  <a:srgbClr val="6E7480"/>
-                </a:solidFill>
-                <a:latin typeface="Calibri" pitchFamily="34" charset="0"/>
-                <a:ea typeface="Calibri" pitchFamily="34" charset="-122"/>
-                <a:cs typeface="Calibri" pitchFamily="34" charset="-120"/>
-              </a:rPr>
-              <a:t>All projects, statuses, and client info — at a glance.</a:t>
-            </a:r>
-            <a:endParaRPr lang="en-US" sz="1100" dirty="0"/>
-          </a:p>
-        </p:txBody>
-      </p:sp>
-      <p:sp>
-        <p:nvSpPr>
-          <p:cNvPr id="10" name="Shape 7"/>
-          <p:cNvSpPr/>
-          <p:nvPr/>
-        </p:nvSpPr>
-        <p:spPr>
-          <a:xfrm>
-            <a:off x="4299052" y="2980944"/>
-            <a:ext cx="3593592" cy="1856232"/>
-          </a:xfrm>
-          <a:prstGeom prst="rect">
-            <a:avLst/>
-          </a:prstGeom>
-          <a:ln w="12700">
-            <a:solidFill>
-              <a:srgbClr val="A88147"/>
-            </a:solidFill>
-            <a:prstDash val="solid"/>
-          </a:ln>
-        </p:spPr>
-      </p:sp>
-      <p:pic>
-        <p:nvPicPr>
-          <p:cNvPr id="11" name="Image 1" descr="C:/Users/SURFACE/Downloads/EWP Quote App/screenshots/02_room_estimates.png">    </p:cNvPr>
-          <p:cNvPicPr>
-            <a:picLocks noChangeAspect="1"/>
-          </p:cNvPicPr>
-          <p:nvPr/>
-        </p:nvPicPr>
-        <p:blipFill>
-          <a:blip r:embed="rId2"/>
-          <a:stretch>
-            <a:fillRect/>
-          </a:stretch>
-        </p:blipFill>
-        <p:spPr>
-          <a:xfrm>
-            <a:off x="4335628" y="3017520"/>
-            <a:ext cx="3520440" cy="1783080"/>
-          </a:xfrm>
-          <a:prstGeom prst="rect">
-            <a:avLst/>
-          </a:prstGeom>
-        </p:spPr>
-      </p:pic>
-      <p:sp>
-        <p:nvSpPr>
-          <p:cNvPr id="12" name="Text 8"/>
-          <p:cNvSpPr/>
-          <p:nvPr/>
-        </p:nvSpPr>
-        <p:spPr>
-          <a:xfrm>
-            <a:off x="4335628" y="4892040"/>
-            <a:ext cx="3520440" cy="365760"/>
-          </a:xfrm>
-          <a:prstGeom prst="rect">
-            <a:avLst/>
-          </a:prstGeom>
-          <a:noFill/>
-          <a:ln/>
-        </p:spPr>
-        <p:txBody>
-          <a:bodyPr wrap="square" rtlCol="0" anchor="ctr"/>
-          <a:lstStyle/>
-          <a:p>
-            <a:pPr algn="ctr" indent="0" marL="0">
-              <a:buNone/>
-            </a:pPr>
-            <a:r>
-              <a:rPr lang="en-US" sz="1800" i="1" dirty="0">
-                <a:solidFill>
-                  <a:srgbClr val="1F242E"/>
-                </a:solidFill>
-                <a:latin typeface="Georgia" pitchFamily="34" charset="0"/>
-                <a:ea typeface="Georgia" pitchFamily="34" charset="-122"/>
-                <a:cs typeface="Georgia" pitchFamily="34" charset="-120"/>
-              </a:rPr>
-              <a:t>Room Estimator</a:t>
-            </a:r>
-            <a:endParaRPr lang="en-US" sz="1800" dirty="0"/>
-          </a:p>
-        </p:txBody>
-      </p:sp>
-      <p:sp>
-        <p:nvSpPr>
-          <p:cNvPr id="13" name="Text 9"/>
-          <p:cNvSpPr/>
-          <p:nvPr/>
-        </p:nvSpPr>
-        <p:spPr>
-          <a:xfrm>
-            <a:off x="4335628" y="5257800"/>
-            <a:ext cx="3520440" cy="457200"/>
-          </a:xfrm>
-          <a:prstGeom prst="rect">
-            <a:avLst/>
-          </a:prstGeom>
-          <a:noFill/>
-          <a:ln/>
-        </p:spPr>
-        <p:txBody>
-          <a:bodyPr wrap="square" rtlCol="0" anchor="ctr"/>
-          <a:lstStyle/>
-          <a:p>
-            <a:pPr algn="ctr" indent="0" marL="0">
-              <a:buNone/>
-            </a:pPr>
-            <a:r>
-              <a:rPr lang="en-US" sz="1100" dirty="0">
-                <a:solidFill>
-                  <a:srgbClr val="6E7480"/>
-                </a:solidFill>
-                <a:latin typeface="Calibri" pitchFamily="34" charset="0"/>
-                <a:ea typeface="Calibri" pitchFamily="34" charset="-122"/>
-                <a:cs typeface="Calibri" pitchFamily="34" charset="-120"/>
-              </a:rPr>
-              <a:t>Drop in items, watch the total update live.</a:t>
-            </a:r>
-            <a:endParaRPr lang="en-US" sz="1100" dirty="0"/>
-          </a:p>
-        </p:txBody>
-      </p:sp>
-      <p:sp>
-        <p:nvSpPr>
-          <p:cNvPr id="14" name="Shape 10"/>
-          <p:cNvSpPr/>
-          <p:nvPr/>
-        </p:nvSpPr>
-        <p:spPr>
-          <a:xfrm>
-            <a:off x="8093812" y="2980944"/>
-            <a:ext cx="3593592" cy="1856232"/>
-          </a:xfrm>
-          <a:prstGeom prst="rect">
-            <a:avLst/>
-          </a:prstGeom>
-          <a:ln w="12700">
-            <a:solidFill>
-              <a:srgbClr val="A88147"/>
-            </a:solidFill>
-            <a:prstDash val="solid"/>
-          </a:ln>
-        </p:spPr>
-      </p:sp>
-      <p:pic>
-        <p:nvPicPr>
-          <p:cNvPr id="15" name="Image 2" descr="C:/Users/SURFACE/Downloads/EWP Quote App/screenshots/03_summary.png">    </p:cNvPr>
+          <p:cNvPr id="7" name="Image 0" descr="C:/Users/SURFACE/Downloads/EWP Quote App/screenshots/01_dashboard.png"/>
           <p:cNvPicPr>
             <a:picLocks noChangeAspect="1"/>
           </p:cNvPicPr>
@@ -4409,7 +4044,7 @@
         </p:blipFill>
         <p:spPr>
           <a:xfrm>
-            <a:off x="8130388" y="3017520"/>
+            <a:off x="540868" y="3017520"/>
             <a:ext cx="3520440" cy="1783080"/>
           </a:xfrm>
           <a:prstGeom prst="rect">
@@ -4419,13 +4054,13 @@
       </p:pic>
       <p:sp>
         <p:nvSpPr>
-          <p:cNvPr id="16" name="Text 11"/>
-          <p:cNvSpPr/>
-          <p:nvPr/>
-        </p:nvSpPr>
-        <p:spPr>
-          <a:xfrm>
-            <a:off x="8130388" y="4892040"/>
+          <p:cNvPr id="8" name="Text 5"/>
+          <p:cNvSpPr/>
+          <p:nvPr/>
+        </p:nvSpPr>
+        <p:spPr>
+          <a:xfrm>
+            <a:off x="540868" y="4892040"/>
             <a:ext cx="3520440" cy="365760"/>
           </a:xfrm>
           <a:prstGeom prst="rect">
@@ -4438,7 +4073,7 @@
           <a:bodyPr wrap="square" rtlCol="0" anchor="ctr"/>
           <a:lstStyle/>
           <a:p>
-            <a:pPr algn="ctr" indent="0" marL="0">
+            <a:pPr marL="0" indent="0" algn="ctr">
               <a:buNone/>
             </a:pPr>
             <a:r>
@@ -4450,7 +4085,7 @@
                 <a:ea typeface="Georgia" pitchFamily="34" charset="-122"/>
                 <a:cs typeface="Georgia" pitchFamily="34" charset="-120"/>
               </a:rPr>
-              <a:t>Quote PDF</a:t>
+              <a:t>Dashboard</a:t>
             </a:r>
             <a:endParaRPr lang="en-US" sz="1800" dirty="0"/>
           </a:p>
@@ -4458,13 +4093,13 @@
       </p:sp>
       <p:sp>
         <p:nvSpPr>
-          <p:cNvPr id="17" name="Text 12"/>
-          <p:cNvSpPr/>
-          <p:nvPr/>
-        </p:nvSpPr>
-        <p:spPr>
-          <a:xfrm>
-            <a:off x="8130388" y="5257800"/>
+          <p:cNvPr id="9" name="Text 6"/>
+          <p:cNvSpPr/>
+          <p:nvPr/>
+        </p:nvSpPr>
+        <p:spPr>
+          <a:xfrm>
+            <a:off x="540868" y="5257800"/>
             <a:ext cx="3520440" cy="457200"/>
           </a:xfrm>
           <a:prstGeom prst="rect">
@@ -4477,7 +4112,7 @@
           <a:bodyPr wrap="square" rtlCol="0" anchor="ctr"/>
           <a:lstStyle/>
           <a:p>
-            <a:pPr algn="ctr" indent="0" marL="0">
+            <a:pPr marL="0" indent="0" algn="ctr">
               <a:buNone/>
             </a:pPr>
             <a:r>
@@ -4489,7 +4124,7 @@
                 <a:ea typeface="Calibri" pitchFamily="34" charset="-122"/>
                 <a:cs typeface="Calibri" pitchFamily="34" charset="-120"/>
               </a:rPr>
-              <a:t>Your branding. Your logo. Sent in one click.</a:t>
+              <a:t>All projects, statuses, and client info — at a glance.</a:t>
             </a:r>
             <a:endParaRPr lang="en-US" sz="1100" dirty="0"/>
           </a:p>
@@ -4497,30 +4132,122 @@
       </p:sp>
       <p:sp>
         <p:nvSpPr>
-          <p:cNvPr id="18" name="Text 13"/>
-          <p:cNvSpPr/>
-          <p:nvPr/>
-        </p:nvSpPr>
-        <p:spPr>
-          <a:xfrm>
-            <a:off x="548640" y="6473952"/>
-            <a:ext cx="5486400" cy="274320"/>
-          </a:xfrm>
-          <a:prstGeom prst="rect">
-            <a:avLst/>
-          </a:prstGeom>
-          <a:noFill/>
-          <a:ln/>
-        </p:spPr>
-        <p:txBody>
-          <a:bodyPr wrap="square" rtlCol="0" anchor="ctr"/>
-          <a:lstStyle/>
-          <a:p>
-            <a:pPr algn="l" indent="0" marL="0">
-              <a:buNone/>
-            </a:pPr>
-            <a:r>
-              <a:rPr lang="en-US" sz="900" i="1" dirty="0">
+          <p:cNvPr id="10" name="Shape 7"/>
+          <p:cNvSpPr/>
+          <p:nvPr/>
+        </p:nvSpPr>
+        <p:spPr>
+          <a:xfrm>
+            <a:off x="4299052" y="2980944"/>
+            <a:ext cx="3593592" cy="1856232"/>
+          </a:xfrm>
+          <a:prstGeom prst="rect">
+            <a:avLst/>
+          </a:prstGeom>
+          <a:ln w="12700">
+            <a:solidFill>
+              <a:srgbClr val="A88147"/>
+            </a:solidFill>
+            <a:prstDash val="solid"/>
+          </a:ln>
+        </p:spPr>
+        <p:txBody>
+          <a:bodyPr/>
+          <a:lstStyle/>
+          <a:p>
+            <a:endParaRPr lang="en-US"/>
+          </a:p>
+        </p:txBody>
+      </p:sp>
+      <p:pic>
+        <p:nvPicPr>
+          <p:cNvPr id="11" name="Image 1" descr="C:/Users/SURFACE/Downloads/EWP Quote App/screenshots/02_room_estimates.png"/>
+          <p:cNvPicPr>
+            <a:picLocks noChangeAspect="1"/>
+          </p:cNvPicPr>
+          <p:nvPr/>
+        </p:nvPicPr>
+        <p:blipFill>
+          <a:blip r:embed="rId4"/>
+          <a:stretch>
+            <a:fillRect/>
+          </a:stretch>
+        </p:blipFill>
+        <p:spPr>
+          <a:xfrm>
+            <a:off x="4335628" y="3017520"/>
+            <a:ext cx="3520440" cy="1783080"/>
+          </a:xfrm>
+          <a:prstGeom prst="rect">
+            <a:avLst/>
+          </a:prstGeom>
+        </p:spPr>
+      </p:pic>
+      <p:sp>
+        <p:nvSpPr>
+          <p:cNvPr id="12" name="Text 8"/>
+          <p:cNvSpPr/>
+          <p:nvPr/>
+        </p:nvSpPr>
+        <p:spPr>
+          <a:xfrm>
+            <a:off x="4335628" y="4892040"/>
+            <a:ext cx="3520440" cy="365760"/>
+          </a:xfrm>
+          <a:prstGeom prst="rect">
+            <a:avLst/>
+          </a:prstGeom>
+          <a:noFill/>
+          <a:ln/>
+        </p:spPr>
+        <p:txBody>
+          <a:bodyPr wrap="square" rtlCol="0" anchor="ctr"/>
+          <a:lstStyle/>
+          <a:p>
+            <a:pPr marL="0" indent="0" algn="ctr">
+              <a:buNone/>
+            </a:pPr>
+            <a:r>
+              <a:rPr lang="en-US" sz="1800" i="1" dirty="0">
+                <a:solidFill>
+                  <a:srgbClr val="1F242E"/>
+                </a:solidFill>
+                <a:latin typeface="Georgia" pitchFamily="34" charset="0"/>
+                <a:ea typeface="Georgia" pitchFamily="34" charset="-122"/>
+                <a:cs typeface="Georgia" pitchFamily="34" charset="-120"/>
+              </a:rPr>
+              <a:t>Room Estimator</a:t>
+            </a:r>
+            <a:endParaRPr lang="en-US" sz="1800" dirty="0"/>
+          </a:p>
+        </p:txBody>
+      </p:sp>
+      <p:sp>
+        <p:nvSpPr>
+          <p:cNvPr id="13" name="Text 9"/>
+          <p:cNvSpPr/>
+          <p:nvPr/>
+        </p:nvSpPr>
+        <p:spPr>
+          <a:xfrm>
+            <a:off x="4335628" y="5257800"/>
+            <a:ext cx="3520440" cy="457200"/>
+          </a:xfrm>
+          <a:prstGeom prst="rect">
+            <a:avLst/>
+          </a:prstGeom>
+          <a:noFill/>
+          <a:ln/>
+        </p:spPr>
+        <p:txBody>
+          <a:bodyPr wrap="square" rtlCol="0" anchor="ctr"/>
+          <a:lstStyle/>
+          <a:p>
+            <a:pPr marL="0" indent="0" algn="ctr">
+              <a:buNone/>
+            </a:pPr>
+            <a:r>
+              <a:rPr lang="en-US" sz="1100" dirty="0">
                 <a:solidFill>
                   <a:srgbClr val="6E7480"/>
                 </a:solidFill>
@@ -4528,6 +4255,176 @@
                 <a:ea typeface="Calibri" pitchFamily="34" charset="-122"/>
                 <a:cs typeface="Calibri" pitchFamily="34" charset="-120"/>
               </a:rPr>
+              <a:t>Drop in items, watch the total update live.</a:t>
+            </a:r>
+            <a:endParaRPr lang="en-US" sz="1100" dirty="0"/>
+          </a:p>
+        </p:txBody>
+      </p:sp>
+      <p:sp>
+        <p:nvSpPr>
+          <p:cNvPr id="14" name="Shape 10"/>
+          <p:cNvSpPr/>
+          <p:nvPr/>
+        </p:nvSpPr>
+        <p:spPr>
+          <a:xfrm>
+            <a:off x="8093812" y="2980944"/>
+            <a:ext cx="3593592" cy="1856232"/>
+          </a:xfrm>
+          <a:prstGeom prst="rect">
+            <a:avLst/>
+          </a:prstGeom>
+          <a:ln w="12700">
+            <a:solidFill>
+              <a:srgbClr val="A88147"/>
+            </a:solidFill>
+            <a:prstDash val="solid"/>
+          </a:ln>
+        </p:spPr>
+        <p:txBody>
+          <a:bodyPr/>
+          <a:lstStyle/>
+          <a:p>
+            <a:endParaRPr lang="en-US"/>
+          </a:p>
+        </p:txBody>
+      </p:sp>
+      <p:pic>
+        <p:nvPicPr>
+          <p:cNvPr id="15" name="Image 2" descr="C:/Users/SURFACE/Downloads/EWP Quote App/screenshots/03_summary.png"/>
+          <p:cNvPicPr>
+            <a:picLocks noChangeAspect="1"/>
+          </p:cNvPicPr>
+          <p:nvPr/>
+        </p:nvPicPr>
+        <p:blipFill>
+          <a:blip r:embed="rId5"/>
+          <a:stretch>
+            <a:fillRect/>
+          </a:stretch>
+        </p:blipFill>
+        <p:spPr>
+          <a:xfrm>
+            <a:off x="8130388" y="3017520"/>
+            <a:ext cx="3520440" cy="1783080"/>
+          </a:xfrm>
+          <a:prstGeom prst="rect">
+            <a:avLst/>
+          </a:prstGeom>
+        </p:spPr>
+      </p:pic>
+      <p:sp>
+        <p:nvSpPr>
+          <p:cNvPr id="16" name="Text 11"/>
+          <p:cNvSpPr/>
+          <p:nvPr/>
+        </p:nvSpPr>
+        <p:spPr>
+          <a:xfrm>
+            <a:off x="8130388" y="4892040"/>
+            <a:ext cx="3520440" cy="365760"/>
+          </a:xfrm>
+          <a:prstGeom prst="rect">
+            <a:avLst/>
+          </a:prstGeom>
+          <a:noFill/>
+          <a:ln/>
+        </p:spPr>
+        <p:txBody>
+          <a:bodyPr wrap="square" rtlCol="0" anchor="ctr"/>
+          <a:lstStyle/>
+          <a:p>
+            <a:pPr marL="0" indent="0" algn="ctr">
+              <a:buNone/>
+            </a:pPr>
+            <a:r>
+              <a:rPr lang="en-US" sz="1800" i="1" dirty="0">
+                <a:solidFill>
+                  <a:srgbClr val="1F242E"/>
+                </a:solidFill>
+                <a:latin typeface="Georgia" pitchFamily="34" charset="0"/>
+                <a:ea typeface="Georgia" pitchFamily="34" charset="-122"/>
+                <a:cs typeface="Georgia" pitchFamily="34" charset="-120"/>
+              </a:rPr>
+              <a:t>Quote PDF</a:t>
+            </a:r>
+            <a:endParaRPr lang="en-US" sz="1800" dirty="0"/>
+          </a:p>
+        </p:txBody>
+      </p:sp>
+      <p:sp>
+        <p:nvSpPr>
+          <p:cNvPr id="17" name="Text 12"/>
+          <p:cNvSpPr/>
+          <p:nvPr/>
+        </p:nvSpPr>
+        <p:spPr>
+          <a:xfrm>
+            <a:off x="8130388" y="5257800"/>
+            <a:ext cx="3520440" cy="457200"/>
+          </a:xfrm>
+          <a:prstGeom prst="rect">
+            <a:avLst/>
+          </a:prstGeom>
+          <a:noFill/>
+          <a:ln/>
+        </p:spPr>
+        <p:txBody>
+          <a:bodyPr wrap="square" rtlCol="0" anchor="ctr"/>
+          <a:lstStyle/>
+          <a:p>
+            <a:pPr marL="0" indent="0" algn="ctr">
+              <a:buNone/>
+            </a:pPr>
+            <a:r>
+              <a:rPr lang="en-US" sz="1100" dirty="0">
+                <a:solidFill>
+                  <a:srgbClr val="6E7480"/>
+                </a:solidFill>
+                <a:latin typeface="Calibri" pitchFamily="34" charset="0"/>
+                <a:ea typeface="Calibri" pitchFamily="34" charset="-122"/>
+                <a:cs typeface="Calibri" pitchFamily="34" charset="-120"/>
+              </a:rPr>
+              <a:t>Your branding. Your logo. Sent in one click.</a:t>
+            </a:r>
+            <a:endParaRPr lang="en-US" sz="1100" dirty="0"/>
+          </a:p>
+        </p:txBody>
+      </p:sp>
+      <p:sp>
+        <p:nvSpPr>
+          <p:cNvPr id="18" name="Text 13"/>
+          <p:cNvSpPr/>
+          <p:nvPr/>
+        </p:nvSpPr>
+        <p:spPr>
+          <a:xfrm>
+            <a:off x="548640" y="6473952"/>
+            <a:ext cx="5486400" cy="274320"/>
+          </a:xfrm>
+          <a:prstGeom prst="rect">
+            <a:avLst/>
+          </a:prstGeom>
+          <a:noFill/>
+          <a:ln/>
+        </p:spPr>
+        <p:txBody>
+          <a:bodyPr wrap="square" rtlCol="0" anchor="ctr"/>
+          <a:lstStyle/>
+          <a:p>
+            <a:pPr marL="0" indent="0" algn="l">
+              <a:buNone/>
+            </a:pPr>
+            <a:r>
+              <a:rPr lang="en-US" sz="900" i="1" dirty="0">
+                <a:solidFill>
+                  <a:srgbClr val="6E7480"/>
+                </a:solidFill>
+                <a:latin typeface="Calibri" pitchFamily="34" charset="0"/>
+                <a:ea typeface="Calibri" pitchFamily="34" charset="-122"/>
+                <a:cs typeface="Calibri" pitchFamily="34" charset="-120"/>
+              </a:rPr>
               <a:t>Quote App for Trade Businesses</a:t>
             </a:r>
             <a:endParaRPr lang="en-US" sz="900" dirty="0"/>
@@ -4555,7 +4452,7 @@
           <a:bodyPr wrap="square" rtlCol="0" anchor="ctr"/>
           <a:lstStyle/>
           <a:p>
-            <a:pPr algn="r" indent="0" marL="0">
+            <a:pPr marL="0" indent="0" algn="r">
               <a:buNone/>
             </a:pPr>
             <a:r>
@@ -4589,6 +4486,7 @@
         <a:solidFill>
           <a:srgbClr val="F2F1ED"/>
         </a:solidFill>
+        <a:effectLst/>
       </p:bgPr>
     </p:bg>
     <p:spTree>
@@ -4624,6 +4522,13 @@
           </a:solidFill>
           <a:ln/>
         </p:spPr>
+        <p:txBody>
+          <a:bodyPr/>
+          <a:lstStyle/>
+          <a:p>
+            <a:endParaRPr lang="en-US"/>
+          </a:p>
+        </p:txBody>
       </p:sp>
       <p:sp>
         <p:nvSpPr>
@@ -4646,11 +4551,11 @@
           <a:bodyPr wrap="square" rtlCol="0" anchor="ctr"/>
           <a:lstStyle/>
           <a:p>
-            <a:pPr indent="0" marL="0">
-              <a:buNone/>
-            </a:pPr>
-            <a:r>
-              <a:rPr lang="en-US" sz="1100" b="1" spc="600" kern="0" dirty="0">
+            <a:pPr marL="0" indent="0">
+              <a:buNone/>
+            </a:pPr>
+            <a:r>
+              <a:rPr lang="en-US" sz="1100" b="1" kern="0" spc="600" dirty="0">
                 <a:solidFill>
                   <a:srgbClr val="A88147"/>
                 </a:solidFill>
@@ -4685,7 +4590,7 @@
           <a:bodyPr wrap="square" rtlCol="0" anchor="ctr"/>
           <a:lstStyle/>
           <a:p>
-            <a:pPr indent="0" marL="0">
+            <a:pPr marL="0" indent="0">
               <a:buNone/>
             </a:pPr>
             <a:r>
@@ -4727,6 +4632,13 @@
             <a:prstDash val="solid"/>
           </a:ln>
         </p:spPr>
+        <p:txBody>
+          <a:bodyPr/>
+          <a:lstStyle/>
+          <a:p>
+            <a:endParaRPr lang="en-US"/>
+          </a:p>
+        </p:txBody>
       </p:sp>
       <p:sp>
         <p:nvSpPr>
@@ -4747,6 +4659,13 @@
           </a:solidFill>
           <a:ln/>
         </p:spPr>
+        <p:txBody>
+          <a:bodyPr/>
+          <a:lstStyle/>
+          <a:p>
+            <a:endParaRPr lang="en-US"/>
+          </a:p>
+        </p:txBody>
       </p:sp>
       <p:sp>
         <p:nvSpPr>
@@ -4769,7 +4688,7 @@
           <a:bodyPr wrap="square" rtlCol="0" anchor="ctr"/>
           <a:lstStyle/>
           <a:p>
-            <a:pPr indent="0" marL="0">
+            <a:pPr marL="0" indent="0">
               <a:buNone/>
             </a:pPr>
             <a:r>
@@ -4808,7 +4727,7 @@
           <a:bodyPr wrap="square" rtlCol="0" anchor="ctr"/>
           <a:lstStyle/>
           <a:p>
-            <a:pPr indent="0" marL="0">
+            <a:pPr marL="0" indent="0">
               <a:buNone/>
             </a:pPr>
             <a:r>
@@ -4847,7 +4766,7 @@
           <a:bodyPr wrap="square" rtlCol="0" anchor="ctr"/>
           <a:lstStyle/>
           <a:p>
-            <a:pPr indent="0" marL="0">
+            <a:pPr marL="0" indent="0">
               <a:buNone/>
             </a:pPr>
             <a:r>
@@ -4889,6 +4808,13 @@
             <a:prstDash val="solid"/>
           </a:ln>
         </p:spPr>
+        <p:txBody>
+          <a:bodyPr/>
+          <a:lstStyle/>
+          <a:p>
+            <a:endParaRPr lang="en-US"/>
+          </a:p>
+        </p:txBody>
       </p:sp>
       <p:sp>
         <p:nvSpPr>
@@ -4909,6 +4835,13 @@
           </a:solidFill>
           <a:ln/>
         </p:spPr>
+        <p:txBody>
+          <a:bodyPr/>
+          <a:lstStyle/>
+          <a:p>
+            <a:endParaRPr lang="en-US"/>
+          </a:p>
+        </p:txBody>
       </p:sp>
       <p:sp>
         <p:nvSpPr>
@@ -4931,7 +4864,7 @@
           <a:bodyPr wrap="square" rtlCol="0" anchor="ctr"/>
           <a:lstStyle/>
           <a:p>
-            <a:pPr indent="0" marL="0">
+            <a:pPr marL="0" indent="0">
               <a:buNone/>
             </a:pPr>
             <a:r>
@@ -4970,7 +4903,7 @@
           <a:bodyPr wrap="square" rtlCol="0" anchor="ctr"/>
           <a:lstStyle/>
           <a:p>
-            <a:pPr indent="0" marL="0">
+            <a:pPr marL="0" indent="0">
               <a:buNone/>
             </a:pPr>
             <a:r>
@@ -5009,7 +4942,7 @@
           <a:bodyPr wrap="square" rtlCol="0" anchor="ctr"/>
           <a:lstStyle/>
           <a:p>
-            <a:pPr indent="0" marL="0">
+            <a:pPr marL="0" indent="0">
               <a:buNone/>
             </a:pPr>
             <a:r>
@@ -5051,6 +4984,13 @@
             <a:prstDash val="solid"/>
           </a:ln>
         </p:spPr>
+        <p:txBody>
+          <a:bodyPr/>
+          <a:lstStyle/>
+          <a:p>
+            <a:endParaRPr lang="en-US"/>
+          </a:p>
+        </p:txBody>
       </p:sp>
       <p:sp>
         <p:nvSpPr>
@@ -5071,6 +5011,13 @@
           </a:solidFill>
           <a:ln/>
         </p:spPr>
+        <p:txBody>
+          <a:bodyPr/>
+          <a:lstStyle/>
+          <a:p>
+            <a:endParaRPr lang="en-US"/>
+          </a:p>
+        </p:txBody>
       </p:sp>
       <p:sp>
         <p:nvSpPr>
@@ -5093,7 +5040,7 @@
           <a:bodyPr wrap="square" rtlCol="0" anchor="ctr"/>
           <a:lstStyle/>
           <a:p>
-            <a:pPr indent="0" marL="0">
+            <a:pPr marL="0" indent="0">
               <a:buNone/>
             </a:pPr>
             <a:r>
@@ -5132,7 +5079,7 @@
           <a:bodyPr wrap="square" rtlCol="0" anchor="ctr"/>
           <a:lstStyle/>
           <a:p>
-            <a:pPr indent="0" marL="0">
+            <a:pPr marL="0" indent="0">
               <a:buNone/>
             </a:pPr>
             <a:r>
@@ -5171,7 +5118,7 @@
           <a:bodyPr wrap="square" rtlCol="0" anchor="ctr"/>
           <a:lstStyle/>
           <a:p>
-            <a:pPr indent="0" marL="0">
+            <a:pPr marL="0" indent="0">
               <a:buNone/>
             </a:pPr>
             <a:r>
@@ -5213,6 +5160,13 @@
             <a:prstDash val="solid"/>
           </a:ln>
         </p:spPr>
+        <p:txBody>
+          <a:bodyPr/>
+          <a:lstStyle/>
+          <a:p>
+            <a:endParaRPr lang="en-US"/>
+          </a:p>
+        </p:txBody>
       </p:sp>
       <p:sp>
         <p:nvSpPr>
@@ -5233,6 +5187,13 @@
           </a:solidFill>
           <a:ln/>
         </p:spPr>
+        <p:txBody>
+          <a:bodyPr/>
+          <a:lstStyle/>
+          <a:p>
+            <a:endParaRPr lang="en-US"/>
+          </a:p>
+        </p:txBody>
       </p:sp>
       <p:sp>
         <p:nvSpPr>
@@ -5255,7 +5216,7 @@
           <a:bodyPr wrap="square" rtlCol="0" anchor="ctr"/>
           <a:lstStyle/>
           <a:p>
-            <a:pPr indent="0" marL="0">
+            <a:pPr marL="0" indent="0">
               <a:buNone/>
             </a:pPr>
             <a:r>
@@ -5294,7 +5255,7 @@
           <a:bodyPr wrap="square" rtlCol="0" anchor="ctr"/>
           <a:lstStyle/>
           <a:p>
-            <a:pPr indent="0" marL="0">
+            <a:pPr marL="0" indent="0">
               <a:buNone/>
             </a:pPr>
             <a:r>
@@ -5333,7 +5294,7 @@
           <a:bodyPr wrap="square" rtlCol="0" anchor="ctr"/>
           <a:lstStyle/>
           <a:p>
-            <a:pPr indent="0" marL="0">
+            <a:pPr marL="0" indent="0">
               <a:buNone/>
             </a:pPr>
             <a:r>
@@ -5372,7 +5333,7 @@
           <a:bodyPr wrap="square" rtlCol="0" anchor="ctr"/>
           <a:lstStyle/>
           <a:p>
-            <a:pPr algn="l" indent="0" marL="0">
+            <a:pPr marL="0" indent="0" algn="l">
               <a:buNone/>
             </a:pPr>
             <a:r>
@@ -5411,7 +5372,7 @@
           <a:bodyPr wrap="square" rtlCol="0" anchor="ctr"/>
           <a:lstStyle/>
           <a:p>
-            <a:pPr algn="r" indent="0" marL="0">
+            <a:pPr marL="0" indent="0" algn="r">
               <a:buNone/>
             </a:pPr>
             <a:r>
@@ -5445,6 +5406,7 @@
         <a:solidFill>
           <a:srgbClr val="F2F1ED"/>
         </a:solidFill>
+        <a:effectLst/>
       </p:bgPr>
     </p:bg>
     <p:spTree>
@@ -5480,6 +5442,13 @@
           </a:solidFill>
           <a:ln/>
         </p:spPr>
+        <p:txBody>
+          <a:bodyPr/>
+          <a:lstStyle/>
+          <a:p>
+            <a:endParaRPr lang="en-US"/>
+          </a:p>
+        </p:txBody>
       </p:sp>
       <p:sp>
         <p:nvSpPr>
@@ -5502,11 +5471,11 @@
           <a:bodyPr wrap="square" rtlCol="0" anchor="ctr"/>
           <a:lstStyle/>
           <a:p>
-            <a:pPr indent="0" marL="0">
-              <a:buNone/>
-            </a:pPr>
-            <a:r>
-              <a:rPr lang="en-US" sz="1100" b="1" spc="600" kern="0" dirty="0">
+            <a:pPr marL="0" indent="0">
+              <a:buNone/>
+            </a:pPr>
+            <a:r>
+              <a:rPr lang="en-US" sz="1100" b="1" kern="0" spc="600" dirty="0">
                 <a:solidFill>
                   <a:srgbClr val="A88147"/>
                 </a:solidFill>
@@ -5541,7 +5510,7 @@
           <a:bodyPr wrap="square" rtlCol="0" anchor="ctr"/>
           <a:lstStyle/>
           <a:p>
-            <a:pPr indent="0" marL="0">
+            <a:pPr marL="0" indent="0">
               <a:buNone/>
             </a:pPr>
             <a:r>
@@ -5583,6 +5552,13 @@
             <a:prstDash val="solid"/>
           </a:ln>
         </p:spPr>
+        <p:txBody>
+          <a:bodyPr/>
+          <a:lstStyle/>
+          <a:p>
+            <a:endParaRPr lang="en-US"/>
+          </a:p>
+        </p:txBody>
       </p:sp>
       <p:sp>
         <p:nvSpPr>
@@ -5603,6 +5579,13 @@
           </a:solidFill>
           <a:ln/>
         </p:spPr>
+        <p:txBody>
+          <a:bodyPr/>
+          <a:lstStyle/>
+          <a:p>
+            <a:endParaRPr lang="en-US"/>
+          </a:p>
+        </p:txBody>
       </p:sp>
       <p:sp>
         <p:nvSpPr>
@@ -5625,7 +5608,7 @@
           <a:bodyPr wrap="square" rtlCol="0" anchor="ctr"/>
           <a:lstStyle/>
           <a:p>
-            <a:pPr indent="0" marL="0">
+            <a:pPr marL="0" indent="0">
               <a:buNone/>
             </a:pPr>
             <a:r>
@@ -5664,7 +5647,7 @@
           <a:bodyPr wrap="square" rtlCol="0" anchor="ctr"/>
           <a:lstStyle/>
           <a:p>
-            <a:pPr indent="0" marL="0">
+            <a:pPr marL="0" indent="0">
               <a:buNone/>
             </a:pPr>
             <a:r>
@@ -5703,7 +5686,7 @@
           <a:bodyPr wrap="square" rtlCol="0" anchor="ctr"/>
           <a:lstStyle/>
           <a:p>
-            <a:pPr indent="0" marL="0">
+            <a:pPr marL="0" indent="0">
               <a:buNone/>
             </a:pPr>
             <a:r>
@@ -5745,6 +5728,13 @@
             <a:prstDash val="solid"/>
           </a:ln>
         </p:spPr>
+        <p:txBody>
+          <a:bodyPr/>
+          <a:lstStyle/>
+          <a:p>
+            <a:endParaRPr lang="en-US"/>
+          </a:p>
+        </p:txBody>
       </p:sp>
       <p:sp>
         <p:nvSpPr>
@@ -5765,6 +5755,13 @@
           </a:solidFill>
           <a:ln/>
         </p:spPr>
+        <p:txBody>
+          <a:bodyPr/>
+          <a:lstStyle/>
+          <a:p>
+            <a:endParaRPr lang="en-US"/>
+          </a:p>
+        </p:txBody>
       </p:sp>
       <p:sp>
         <p:nvSpPr>
@@ -5787,7 +5784,7 @@
           <a:bodyPr wrap="square" rtlCol="0" anchor="ctr"/>
           <a:lstStyle/>
           <a:p>
-            <a:pPr indent="0" marL="0">
+            <a:pPr marL="0" indent="0">
               <a:buNone/>
             </a:pPr>
             <a:r>
@@ -5826,7 +5823,7 @@
           <a:bodyPr wrap="square" rtlCol="0" anchor="ctr"/>
           <a:lstStyle/>
           <a:p>
-            <a:pPr indent="0" marL="0">
+            <a:pPr marL="0" indent="0">
               <a:buNone/>
             </a:pPr>
             <a:r>
@@ -5865,7 +5862,7 @@
           <a:bodyPr wrap="square" rtlCol="0" anchor="ctr"/>
           <a:lstStyle/>
           <a:p>
-            <a:pPr indent="0" marL="0">
+            <a:pPr marL="0" indent="0">
               <a:buNone/>
             </a:pPr>
             <a:r>
@@ -5907,6 +5904,13 @@
             <a:prstDash val="solid"/>
           </a:ln>
         </p:spPr>
+        <p:txBody>
+          <a:bodyPr/>
+          <a:lstStyle/>
+          <a:p>
+            <a:endParaRPr lang="en-US"/>
+          </a:p>
+        </p:txBody>
       </p:sp>
       <p:sp>
         <p:nvSpPr>
@@ -5927,6 +5931,13 @@
           </a:solidFill>
           <a:ln/>
         </p:spPr>
+        <p:txBody>
+          <a:bodyPr/>
+          <a:lstStyle/>
+          <a:p>
+            <a:endParaRPr lang="en-US"/>
+          </a:p>
+        </p:txBody>
       </p:sp>
       <p:sp>
         <p:nvSpPr>
@@ -5949,7 +5960,7 @@
           <a:bodyPr wrap="square" rtlCol="0" anchor="ctr"/>
           <a:lstStyle/>
           <a:p>
-            <a:pPr indent="0" marL="0">
+            <a:pPr marL="0" indent="0">
               <a:buNone/>
             </a:pPr>
             <a:r>
@@ -5988,7 +5999,7 @@
           <a:bodyPr wrap="square" rtlCol="0" anchor="ctr"/>
           <a:lstStyle/>
           <a:p>
-            <a:pPr indent="0" marL="0">
+            <a:pPr marL="0" indent="0">
               <a:buNone/>
             </a:pPr>
             <a:r>
@@ -6027,7 +6038,7 @@
           <a:bodyPr wrap="square" rtlCol="0" anchor="ctr"/>
           <a:lstStyle/>
           <a:p>
-            <a:pPr indent="0" marL="0">
+            <a:pPr marL="0" indent="0">
               <a:buNone/>
             </a:pPr>
             <a:r>
@@ -6069,6 +6080,13 @@
             <a:prstDash val="solid"/>
           </a:ln>
         </p:spPr>
+        <p:txBody>
+          <a:bodyPr/>
+          <a:lstStyle/>
+          <a:p>
+            <a:endParaRPr lang="en-US"/>
+          </a:p>
+        </p:txBody>
       </p:sp>
       <p:sp>
         <p:nvSpPr>
@@ -6089,6 +6107,13 @@
           </a:solidFill>
           <a:ln/>
         </p:spPr>
+        <p:txBody>
+          <a:bodyPr/>
+          <a:lstStyle/>
+          <a:p>
+            <a:endParaRPr lang="en-US"/>
+          </a:p>
+        </p:txBody>
       </p:sp>
       <p:sp>
         <p:nvSpPr>
@@ -6111,7 +6136,7 @@
           <a:bodyPr wrap="square" rtlCol="0" anchor="ctr"/>
           <a:lstStyle/>
           <a:p>
-            <a:pPr indent="0" marL="0">
+            <a:pPr marL="0" indent="0">
               <a:buNone/>
             </a:pPr>
             <a:r>
@@ -6150,7 +6175,7 @@
           <a:bodyPr wrap="square" rtlCol="0" anchor="ctr"/>
           <a:lstStyle/>
           <a:p>
-            <a:pPr indent="0" marL="0">
+            <a:pPr marL="0" indent="0">
               <a:buNone/>
             </a:pPr>
             <a:r>
@@ -6189,7 +6214,7 @@
           <a:bodyPr wrap="square" rtlCol="0" anchor="ctr"/>
           <a:lstStyle/>
           <a:p>
-            <a:pPr indent="0" marL="0">
+            <a:pPr marL="0" indent="0">
               <a:buNone/>
             </a:pPr>
             <a:r>
@@ -6228,7 +6253,7 @@
           <a:bodyPr wrap="square" rtlCol="0" anchor="ctr"/>
           <a:lstStyle/>
           <a:p>
-            <a:pPr algn="l" indent="0" marL="0">
+            <a:pPr marL="0" indent="0" algn="l">
               <a:buNone/>
             </a:pPr>
             <a:r>
@@ -6267,7 +6292,7 @@
           <a:bodyPr wrap="square" rtlCol="0" anchor="ctr"/>
           <a:lstStyle/>
           <a:p>
-            <a:pPr algn="r" indent="0" marL="0">
+            <a:pPr marL="0" indent="0" algn="r">
               <a:buNone/>
             </a:pPr>
             <a:r>
@@ -6301,6 +6326,7 @@
         <a:solidFill>
           <a:srgbClr val="F2F1ED"/>
         </a:solidFill>
+        <a:effectLst/>
       </p:bgPr>
     </p:bg>
     <p:spTree>
@@ -6336,6 +6362,13 @@
           </a:solidFill>
           <a:ln/>
         </p:spPr>
+        <p:txBody>
+          <a:bodyPr/>
+          <a:lstStyle/>
+          <a:p>
+            <a:endParaRPr lang="en-US"/>
+          </a:p>
+        </p:txBody>
       </p:sp>
       <p:sp>
         <p:nvSpPr>
@@ -6358,11 +6391,11 @@
           <a:bodyPr wrap="square" rtlCol="0" anchor="ctr"/>
           <a:lstStyle/>
           <a:p>
-            <a:pPr indent="0" marL="0">
-              <a:buNone/>
-            </a:pPr>
-            <a:r>
-              <a:rPr lang="en-US" sz="1100" b="1" spc="600" kern="0" dirty="0">
+            <a:pPr marL="0" indent="0">
+              <a:buNone/>
+            </a:pPr>
+            <a:r>
+              <a:rPr lang="en-US" sz="1100" b="1" kern="0" spc="600" dirty="0">
                 <a:solidFill>
                   <a:srgbClr val="A88147"/>
                 </a:solidFill>
@@ -6397,7 +6430,7 @@
           <a:bodyPr wrap="square" rtlCol="0" anchor="ctr"/>
           <a:lstStyle/>
           <a:p>
-            <a:pPr indent="0" marL="0">
+            <a:pPr marL="0" indent="0">
               <a:buNone/>
             </a:pPr>
             <a:r>
@@ -6434,6 +6467,13 @@
           </a:solidFill>
           <a:ln/>
         </p:spPr>
+        <p:txBody>
+          <a:bodyPr/>
+          <a:lstStyle/>
+          <a:p>
+            <a:endParaRPr lang="en-US"/>
+          </a:p>
+        </p:txBody>
       </p:sp>
       <p:sp>
         <p:nvSpPr>
@@ -6456,11 +6496,11 @@
           <a:bodyPr wrap="square" rtlCol="0" anchor="ctr"/>
           <a:lstStyle/>
           <a:p>
-            <a:pPr indent="0" marL="0">
-              <a:buNone/>
-            </a:pPr>
-            <a:r>
-              <a:rPr lang="en-US" sz="1100" b="1" spc="400" kern="0" dirty="0">
+            <a:pPr marL="0" indent="0">
+              <a:buNone/>
+            </a:pPr>
+            <a:r>
+              <a:rPr lang="en-US" sz="1100" b="1" kern="0" spc="400" dirty="0">
                 <a:solidFill>
                   <a:srgbClr val="C99E64"/>
                 </a:solidFill>
@@ -6495,11 +6535,11 @@
           <a:bodyPr wrap="square" rtlCol="0" anchor="ctr"/>
           <a:lstStyle/>
           <a:p>
-            <a:pPr indent="0" marL="0">
-              <a:buNone/>
-            </a:pPr>
-            <a:r>
-              <a:rPr lang="en-US" sz="1100" b="1" spc="400" kern="0" dirty="0">
+            <a:pPr marL="0" indent="0">
+              <a:buNone/>
+            </a:pPr>
+            <a:r>
+              <a:rPr lang="en-US" sz="1100" b="1" kern="0" spc="400" dirty="0">
                 <a:solidFill>
                   <a:srgbClr val="C99E64"/>
                 </a:solidFill>
@@ -6532,6 +6572,13 @@
           </a:solidFill>
           <a:ln/>
         </p:spPr>
+        <p:txBody>
+          <a:bodyPr/>
+          <a:lstStyle/>
+          <a:p>
+            <a:endParaRPr lang="en-US"/>
+          </a:p>
+        </p:txBody>
       </p:sp>
       <p:sp>
         <p:nvSpPr>
@@ -6552,6 +6599,13 @@
           </a:solidFill>
           <a:ln/>
         </p:spPr>
+        <p:txBody>
+          <a:bodyPr/>
+          <a:lstStyle/>
+          <a:p>
+            <a:endParaRPr lang="en-US"/>
+          </a:p>
+        </p:txBody>
       </p:sp>
       <p:sp>
         <p:nvSpPr>
@@ -6574,7 +6628,7 @@
           <a:bodyPr wrap="square" rtlCol="0" anchor="ctr"/>
           <a:lstStyle/>
           <a:p>
-            <a:pPr indent="0" marL="0">
+            <a:pPr marL="0" indent="0">
               <a:buNone/>
             </a:pPr>
             <a:r>
@@ -6613,7 +6667,7 @@
           <a:bodyPr wrap="square" rtlCol="0" anchor="ctr"/>
           <a:lstStyle/>
           <a:p>
-            <a:pPr indent="0" marL="0">
+            <a:pPr marL="0" indent="0">
               <a:buNone/>
             </a:pPr>
             <a:r>
@@ -6650,6 +6704,13 @@
           </a:solidFill>
           <a:ln/>
         </p:spPr>
+        <p:txBody>
+          <a:bodyPr/>
+          <a:lstStyle/>
+          <a:p>
+            <a:endParaRPr lang="en-US"/>
+          </a:p>
+        </p:txBody>
       </p:sp>
       <p:sp>
         <p:nvSpPr>
@@ -6672,7 +6733,7 @@
           <a:bodyPr wrap="square" rtlCol="0" anchor="ctr"/>
           <a:lstStyle/>
           <a:p>
-            <a:pPr indent="0" marL="0">
+            <a:pPr marL="0" indent="0">
               <a:buNone/>
             </a:pPr>
             <a:r>
@@ -6711,7 +6772,7 @@
           <a:bodyPr wrap="square" rtlCol="0" anchor="ctr"/>
           <a:lstStyle/>
           <a:p>
-            <a:pPr indent="0" marL="0">
+            <a:pPr marL="0" indent="0">
               <a:buNone/>
             </a:pPr>
             <a:r>
@@ -6748,6 +6809,13 @@
           </a:solidFill>
           <a:ln/>
         </p:spPr>
+        <p:txBody>
+          <a:bodyPr/>
+          <a:lstStyle/>
+          <a:p>
+            <a:endParaRPr lang="en-US"/>
+          </a:p>
+        </p:txBody>
       </p:sp>
       <p:sp>
         <p:nvSpPr>
@@ -6768,6 +6836,13 @@
           </a:solidFill>
           <a:ln/>
         </p:spPr>
+        <p:txBody>
+          <a:bodyPr/>
+          <a:lstStyle/>
+          <a:p>
+            <a:endParaRPr lang="en-US"/>
+          </a:p>
+        </p:txBody>
       </p:sp>
       <p:sp>
         <p:nvSpPr>
@@ -6790,7 +6865,7 @@
           <a:bodyPr wrap="square" rtlCol="0" anchor="ctr"/>
           <a:lstStyle/>
           <a:p>
-            <a:pPr indent="0" marL="0">
+            <a:pPr marL="0" indent="0">
               <a:buNone/>
             </a:pPr>
             <a:r>
@@ -6829,7 +6904,7 @@
           <a:bodyPr wrap="square" rtlCol="0" anchor="ctr"/>
           <a:lstStyle/>
           <a:p>
-            <a:pPr indent="0" marL="0">
+            <a:pPr marL="0" indent="0">
               <a:buNone/>
             </a:pPr>
             <a:r>
@@ -6866,6 +6941,13 @@
           </a:solidFill>
           <a:ln/>
         </p:spPr>
+        <p:txBody>
+          <a:bodyPr/>
+          <a:lstStyle/>
+          <a:p>
+            <a:endParaRPr lang="en-US"/>
+          </a:p>
+        </p:txBody>
       </p:sp>
       <p:sp>
         <p:nvSpPr>
@@ -6888,7 +6970,7 @@
           <a:bodyPr wrap="square" rtlCol="0" anchor="ctr"/>
           <a:lstStyle/>
           <a:p>
-            <a:pPr indent="0" marL="0">
+            <a:pPr marL="0" indent="0">
               <a:buNone/>
             </a:pPr>
             <a:r>
@@ -6927,7 +7009,7 @@
           <a:bodyPr wrap="square" rtlCol="0" anchor="ctr"/>
           <a:lstStyle/>
           <a:p>
-            <a:pPr indent="0" marL="0">
+            <a:pPr marL="0" indent="0">
               <a:buNone/>
             </a:pPr>
             <a:r>
@@ -6964,6 +7046,13 @@
           </a:solidFill>
           <a:ln/>
         </p:spPr>
+        <p:txBody>
+          <a:bodyPr/>
+          <a:lstStyle/>
+          <a:p>
+            <a:endParaRPr lang="en-US"/>
+          </a:p>
+        </p:txBody>
       </p:sp>
       <p:sp>
         <p:nvSpPr>
@@ -6984,6 +7073,13 @@
           </a:solidFill>
           <a:ln/>
         </p:spPr>
+        <p:txBody>
+          <a:bodyPr/>
+          <a:lstStyle/>
+          <a:p>
+            <a:endParaRPr lang="en-US"/>
+          </a:p>
+        </p:txBody>
       </p:sp>
       <p:sp>
         <p:nvSpPr>
@@ -7006,7 +7102,7 @@
           <a:bodyPr wrap="square" rtlCol="0" anchor="ctr"/>
           <a:lstStyle/>
           <a:p>
-            <a:pPr indent="0" marL="0">
+            <a:pPr marL="0" indent="0">
               <a:buNone/>
             </a:pPr>
             <a:r>
@@ -7045,7 +7141,7 @@
           <a:bodyPr wrap="square" rtlCol="0" anchor="ctr"/>
           <a:lstStyle/>
           <a:p>
-            <a:pPr indent="0" marL="0">
+            <a:pPr marL="0" indent="0">
               <a:buNone/>
             </a:pPr>
             <a:r>
@@ -7084,7 +7180,7 @@
           <a:bodyPr wrap="square" rtlCol="0" anchor="ctr"/>
           <a:lstStyle/>
           <a:p>
-            <a:pPr algn="ctr" indent="0" marL="0">
+            <a:pPr marL="0" indent="0" algn="ctr">
               <a:buNone/>
             </a:pPr>
             <a:r>
@@ -7123,7 +7219,7 @@
           <a:bodyPr wrap="square" rtlCol="0" anchor="ctr"/>
           <a:lstStyle/>
           <a:p>
-            <a:pPr algn="l" indent="0" marL="0">
+            <a:pPr marL="0" indent="0" algn="l">
               <a:buNone/>
             </a:pPr>
             <a:r>
@@ -7162,7 +7258,7 @@
           <a:bodyPr wrap="square" rtlCol="0" anchor="ctr"/>
           <a:lstStyle/>
           <a:p>
-            <a:pPr algn="r" indent="0" marL="0">
+            <a:pPr marL="0" indent="0" algn="r">
               <a:buNone/>
             </a:pPr>
             <a:r>
@@ -7196,6 +7292,7 @@
         <a:solidFill>
           <a:srgbClr val="1F242E"/>
         </a:solidFill>
+        <a:effectLst/>
       </p:bgPr>
     </p:bg>
     <p:spTree>
@@ -7231,6 +7328,13 @@
           </a:solidFill>
           <a:ln/>
         </p:spPr>
+        <p:txBody>
+          <a:bodyPr/>
+          <a:lstStyle/>
+          <a:p>
+            <a:endParaRPr lang="en-US"/>
+          </a:p>
+        </p:txBody>
       </p:sp>
       <p:sp>
         <p:nvSpPr>
@@ -7253,11 +7357,11 @@
           <a:bodyPr wrap="square" rtlCol="0" anchor="ctr"/>
           <a:lstStyle/>
           <a:p>
-            <a:pPr indent="0" marL="0">
-              <a:buNone/>
-            </a:pPr>
-            <a:r>
-              <a:rPr lang="en-US" sz="1100" b="1" spc="600" kern="0" dirty="0">
+            <a:pPr marL="0" indent="0">
+              <a:buNone/>
+            </a:pPr>
+            <a:r>
+              <a:rPr lang="en-US" sz="1100" b="1" kern="0" spc="600" dirty="0">
                 <a:solidFill>
                   <a:srgbClr val="C99E64"/>
                 </a:solidFill>
@@ -7292,7 +7396,7 @@
           <a:bodyPr wrap="square" rtlCol="0" anchor="ctr"/>
           <a:lstStyle/>
           <a:p>
-            <a:pPr indent="0" marL="0">
+            <a:pPr marL="0" indent="0">
               <a:buNone/>
             </a:pPr>
             <a:r>
@@ -7331,7 +7435,7 @@
           <a:bodyPr wrap="square" rtlCol="0" anchor="ctr"/>
           <a:lstStyle/>
           <a:p>
-            <a:pPr indent="0" marL="0">
+            <a:pPr marL="0" indent="0">
               <a:buNone/>
             </a:pPr>
             <a:r>
@@ -7368,6 +7472,13 @@
           </a:solidFill>
           <a:ln/>
         </p:spPr>
+        <p:txBody>
+          <a:bodyPr/>
+          <a:lstStyle/>
+          <a:p>
+            <a:endParaRPr lang="en-US"/>
+          </a:p>
+        </p:txBody>
       </p:sp>
       <p:sp>
         <p:nvSpPr>
@@ -7388,6 +7499,13 @@
           </a:solidFill>
           <a:ln/>
         </p:spPr>
+        <p:txBody>
+          <a:bodyPr/>
+          <a:lstStyle/>
+          <a:p>
+            <a:endParaRPr lang="en-US"/>
+          </a:p>
+        </p:txBody>
       </p:sp>
       <p:sp>
         <p:nvSpPr>
@@ -7410,7 +7528,7 @@
           <a:bodyPr wrap="square" rtlCol="0" anchor="ctr"/>
           <a:lstStyle/>
           <a:p>
-            <a:pPr indent="0" marL="0">
+            <a:pPr marL="0" indent="0">
               <a:buNone/>
             </a:pPr>
             <a:r>
@@ -7449,7 +7567,7 @@
           <a:bodyPr wrap="square" rtlCol="0" anchor="ctr"/>
           <a:lstStyle/>
           <a:p>
-            <a:pPr indent="0" marL="0">
+            <a:pPr marL="0" indent="0">
               <a:buNone/>
             </a:pPr>
             <a:r>
@@ -7486,6 +7604,13 @@
           </a:solidFill>
           <a:ln/>
         </p:spPr>
+        <p:txBody>
+          <a:bodyPr/>
+          <a:lstStyle/>
+          <a:p>
+            <a:endParaRPr lang="en-US"/>
+          </a:p>
+        </p:txBody>
       </p:sp>
       <p:sp>
         <p:nvSpPr>
@@ -7506,6 +7631,13 @@
           </a:solidFill>
           <a:ln/>
         </p:spPr>
+        <p:txBody>
+          <a:bodyPr/>
+          <a:lstStyle/>
+          <a:p>
+            <a:endParaRPr lang="en-US"/>
+          </a:p>
+        </p:txBody>
       </p:sp>
       <p:sp>
         <p:nvSpPr>
@@ -7528,7 +7660,7 @@
           <a:bodyPr wrap="square" rtlCol="0" anchor="ctr"/>
           <a:lstStyle/>
           <a:p>
-            <a:pPr indent="0" marL="0">
+            <a:pPr marL="0" indent="0">
               <a:buNone/>
             </a:pPr>
             <a:r>
@@ -7567,7 +7699,7 @@
           <a:bodyPr wrap="square" rtlCol="0" anchor="ctr"/>
           <a:lstStyle/>
           <a:p>
-            <a:pPr indent="0" marL="0">
+            <a:pPr marL="0" indent="0">
               <a:buNone/>
             </a:pPr>
             <a:r>
@@ -7604,6 +7736,13 @@
           </a:solidFill>
           <a:ln/>
         </p:spPr>
+        <p:txBody>
+          <a:bodyPr/>
+          <a:lstStyle/>
+          <a:p>
+            <a:endParaRPr lang="en-US"/>
+          </a:p>
+        </p:txBody>
       </p:sp>
       <p:sp>
         <p:nvSpPr>
@@ -7624,6 +7763,13 @@
           </a:solidFill>
           <a:ln/>
         </p:spPr>
+        <p:txBody>
+          <a:bodyPr/>
+          <a:lstStyle/>
+          <a:p>
+            <a:endParaRPr lang="en-US"/>
+          </a:p>
+        </p:txBody>
       </p:sp>
       <p:sp>
         <p:nvSpPr>
@@ -7646,7 +7792,7 @@
           <a:bodyPr wrap="square" rtlCol="0" anchor="ctr"/>
           <a:lstStyle/>
           <a:p>
-            <a:pPr indent="0" marL="0">
+            <a:pPr marL="0" indent="0">
               <a:buNone/>
             </a:pPr>
             <a:r>
@@ -7685,7 +7831,7 @@
           <a:bodyPr wrap="square" rtlCol="0" anchor="ctr"/>
           <a:lstStyle/>
           <a:p>
-            <a:pPr indent="0" marL="0">
+            <a:pPr marL="0" indent="0">
               <a:buNone/>
             </a:pPr>
             <a:r>
@@ -7722,6 +7868,13 @@
           </a:solidFill>
           <a:ln/>
         </p:spPr>
+        <p:txBody>
+          <a:bodyPr/>
+          <a:lstStyle/>
+          <a:p>
+            <a:endParaRPr lang="en-US"/>
+          </a:p>
+        </p:txBody>
       </p:sp>
       <p:sp>
         <p:nvSpPr>
@@ -7742,6 +7895,13 @@
           </a:solidFill>
           <a:ln/>
         </p:spPr>
+        <p:txBody>
+          <a:bodyPr/>
+          <a:lstStyle/>
+          <a:p>
+            <a:endParaRPr lang="en-US"/>
+          </a:p>
+        </p:txBody>
       </p:sp>
       <p:sp>
         <p:nvSpPr>
@@ -7764,7 +7924,7 @@
           <a:bodyPr wrap="square" rtlCol="0" anchor="ctr"/>
           <a:lstStyle/>
           <a:p>
-            <a:pPr indent="0" marL="0">
+            <a:pPr marL="0" indent="0">
               <a:buNone/>
             </a:pPr>
             <a:r>
@@ -7803,7 +7963,7 @@
           <a:bodyPr wrap="square" rtlCol="0" anchor="ctr"/>
           <a:lstStyle/>
           <a:p>
-            <a:pPr indent="0" marL="0">
+            <a:pPr marL="0" indent="0">
               <a:buNone/>
             </a:pPr>
             <a:r>
@@ -7842,7 +8002,7 @@
           <a:bodyPr wrap="square" rtlCol="0" anchor="ctr"/>
           <a:lstStyle/>
           <a:p>
-            <a:pPr indent="0" marL="0">
+            <a:pPr marL="0" indent="0">
               <a:buNone/>
             </a:pPr>
             <a:r>
@@ -7868,8 +8028,8 @@
         </p:nvSpPr>
         <p:spPr>
           <a:xfrm>
-            <a:off x="6309360" y="274320"/>
-            <a:ext cx="5650992" cy="5989320"/>
+            <a:off x="6447382" y="2502469"/>
+            <a:ext cx="5650992" cy="3021887"/>
           </a:xfrm>
           <a:prstGeom prst="rect">
             <a:avLst/>
@@ -7884,25 +8044,31 @@
             <a:prstDash val="solid"/>
           </a:ln>
         </p:spPr>
+        <p:txBody>
+          <a:bodyPr/>
+          <a:lstStyle/>
+          <a:p>
+            <a:endParaRPr lang="en-US"/>
+          </a:p>
+        </p:txBody>
       </p:sp>
       <p:pic>
         <p:nvPicPr>
-          <p:cNvPr id="24" name="Image 0" descr="C:/Users/SURFACE/Downloads/EWP Quote App/screenshots/01_dashboard.png">    </p:cNvPr>
+          <p:cNvPr id="24" name="Image 0"/>
           <p:cNvPicPr>
             <a:picLocks noChangeAspect="1"/>
           </p:cNvPicPr>
           <p:nvPr/>
         </p:nvPicPr>
         <p:blipFill>
-          <a:blip r:embed="rId1"/>
-          <a:stretch>
-            <a:fillRect/>
-          </a:stretch>
+          <a:blip r:embed="rId3"/>
+          <a:srcRect/>
+          <a:stretch/>
         </p:blipFill>
         <p:spPr>
           <a:xfrm>
-            <a:off x="6309360" y="274320"/>
-            <a:ext cx="5650992" cy="5989320"/>
+            <a:off x="6447382" y="2536406"/>
+            <a:ext cx="5650992" cy="2987950"/>
           </a:xfrm>
           <a:prstGeom prst="rect">
             <a:avLst/>
@@ -7930,7 +8096,7 @@
           <a:bodyPr wrap="square" rtlCol="0" anchor="ctr"/>
           <a:lstStyle/>
           <a:p>
-            <a:pPr algn="l" indent="0" marL="0">
+            <a:pPr marL="0" indent="0" algn="l">
               <a:buNone/>
             </a:pPr>
             <a:r>
@@ -7969,7 +8135,7 @@
           <a:bodyPr wrap="square" rtlCol="0" anchor="ctr"/>
           <a:lstStyle/>
           <a:p>
-            <a:pPr algn="r" indent="0" marL="0">
+            <a:pPr marL="0" indent="0" algn="r">
               <a:buNone/>
             </a:pPr>
             <a:r>
@@ -8003,6 +8169,7 @@
         <a:solidFill>
           <a:srgbClr val="F2F1ED"/>
         </a:solidFill>
+        <a:effectLst/>
       </p:bgPr>
     </p:bg>
     <p:spTree>
@@ -8038,6 +8205,13 @@
           </a:solidFill>
           <a:ln/>
         </p:spPr>
+        <p:txBody>
+          <a:bodyPr/>
+          <a:lstStyle/>
+          <a:p>
+            <a:endParaRPr lang="en-US"/>
+          </a:p>
+        </p:txBody>
       </p:sp>
       <p:sp>
         <p:nvSpPr>
@@ -8060,11 +8234,11 @@
           <a:bodyPr wrap="square" rtlCol="0" anchor="ctr"/>
           <a:lstStyle/>
           <a:p>
-            <a:pPr indent="0" marL="0">
-              <a:buNone/>
-            </a:pPr>
-            <a:r>
-              <a:rPr lang="en-US" sz="1100" b="1" spc="600" kern="0" dirty="0">
+            <a:pPr marL="0" indent="0">
+              <a:buNone/>
+            </a:pPr>
+            <a:r>
+              <a:rPr lang="en-US" sz="1100" b="1" kern="0" spc="600" dirty="0">
                 <a:solidFill>
                   <a:srgbClr val="A88147"/>
                 </a:solidFill>
@@ -8099,7 +8273,7 @@
           <a:bodyPr wrap="square" rtlCol="0" anchor="ctr"/>
           <a:lstStyle/>
           <a:p>
-            <a:pPr indent="0" marL="0">
+            <a:pPr marL="0" indent="0">
               <a:buNone/>
             </a:pPr>
             <a:r>
@@ -8136,6 +8310,13 @@
           </a:solidFill>
           <a:ln/>
         </p:spPr>
+        <p:txBody>
+          <a:bodyPr/>
+          <a:lstStyle/>
+          <a:p>
+            <a:endParaRPr lang="en-US"/>
+          </a:p>
+        </p:txBody>
       </p:sp>
       <p:sp>
         <p:nvSpPr>
@@ -8158,7 +8339,7 @@
           <a:bodyPr wrap="square" rtlCol="0" anchor="ctr"/>
           <a:lstStyle/>
           <a:p>
-            <a:pPr indent="0" marL="0">
+            <a:pPr marL="0" indent="0">
               <a:buNone/>
             </a:pPr>
             <a:r>
@@ -8197,7 +8378,7 @@
           <a:bodyPr wrap="square" rtlCol="0" anchor="ctr"/>
           <a:lstStyle/>
           <a:p>
-            <a:pPr indent="0" marL="0">
+            <a:pPr marL="0" indent="0">
               <a:buNone/>
             </a:pPr>
             <a:r>
@@ -8234,6 +8415,13 @@
           </a:solidFill>
           <a:ln/>
         </p:spPr>
+        <p:txBody>
+          <a:bodyPr/>
+          <a:lstStyle/>
+          <a:p>
+            <a:endParaRPr lang="en-US"/>
+          </a:p>
+        </p:txBody>
       </p:sp>
       <p:sp>
         <p:nvSpPr>
@@ -8256,7 +8444,7 @@
           <a:bodyPr wrap="square" rtlCol="0" anchor="ctr"/>
           <a:lstStyle/>
           <a:p>
-            <a:pPr indent="0" marL="0">
+            <a:pPr marL="0" indent="0">
               <a:buNone/>
             </a:pPr>
             <a:r>
@@ -8295,7 +8483,7 @@
           <a:bodyPr wrap="square" rtlCol="0" anchor="ctr"/>
           <a:lstStyle/>
           <a:p>
-            <a:pPr indent="0" marL="0">
+            <a:pPr marL="0" indent="0">
               <a:buNone/>
             </a:pPr>
             <a:r>
@@ -8332,6 +8520,13 @@
           </a:solidFill>
           <a:ln/>
         </p:spPr>
+        <p:txBody>
+          <a:bodyPr/>
+          <a:lstStyle/>
+          <a:p>
+            <a:endParaRPr lang="en-US"/>
+          </a:p>
+        </p:txBody>
       </p:sp>
       <p:sp>
         <p:nvSpPr>
@@ -8354,7 +8549,7 @@
           <a:bodyPr wrap="square" rtlCol="0" anchor="ctr"/>
           <a:lstStyle/>
           <a:p>
-            <a:pPr indent="0" marL="0">
+            <a:pPr marL="0" indent="0">
               <a:buNone/>
             </a:pPr>
             <a:r>
@@ -8393,7 +8588,7 @@
           <a:bodyPr wrap="square" rtlCol="0" anchor="ctr"/>
           <a:lstStyle/>
           <a:p>
-            <a:pPr indent="0" marL="0">
+            <a:pPr marL="0" indent="0">
               <a:buNone/>
             </a:pPr>
             <a:r>
@@ -8430,6 +8625,13 @@
           </a:solidFill>
           <a:ln/>
         </p:spPr>
+        <p:txBody>
+          <a:bodyPr/>
+          <a:lstStyle/>
+          <a:p>
+            <a:endParaRPr lang="en-US"/>
+          </a:p>
+        </p:txBody>
       </p:sp>
       <p:sp>
         <p:nvSpPr>
@@ -8452,7 +8654,7 @@
           <a:bodyPr wrap="square" rtlCol="0" anchor="ctr"/>
           <a:lstStyle/>
           <a:p>
-            <a:pPr indent="0" marL="0">
+            <a:pPr marL="0" indent="0">
               <a:buNone/>
             </a:pPr>
             <a:r>
@@ -8491,7 +8693,7 @@
           <a:bodyPr wrap="square" rtlCol="0" anchor="ctr"/>
           <a:lstStyle/>
           <a:p>
-            <a:pPr indent="0" marL="0">
+            <a:pPr marL="0" indent="0">
               <a:buNone/>
             </a:pPr>
             <a:r>
@@ -8528,6 +8730,13 @@
           </a:solidFill>
           <a:ln/>
         </p:spPr>
+        <p:txBody>
+          <a:bodyPr/>
+          <a:lstStyle/>
+          <a:p>
+            <a:endParaRPr lang="en-US"/>
+          </a:p>
+        </p:txBody>
       </p:sp>
       <p:sp>
         <p:nvSpPr>
@@ -8550,7 +8759,7 @@
           <a:bodyPr wrap="square" rtlCol="0" anchor="ctr"/>
           <a:lstStyle/>
           <a:p>
-            <a:pPr indent="0" marL="0">
+            <a:pPr marL="0" indent="0">
               <a:buNone/>
             </a:pPr>
             <a:r>
@@ -8589,7 +8798,7 @@
           <a:bodyPr wrap="square" rtlCol="0" anchor="ctr"/>
           <a:lstStyle/>
           <a:p>
-            <a:pPr indent="0" marL="0">
+            <a:pPr marL="0" indent="0">
               <a:buNone/>
             </a:pPr>
             <a:r>
@@ -8626,6 +8835,13 @@
           </a:solidFill>
           <a:ln/>
         </p:spPr>
+        <p:txBody>
+          <a:bodyPr/>
+          <a:lstStyle/>
+          <a:p>
+            <a:endParaRPr lang="en-US"/>
+          </a:p>
+        </p:txBody>
       </p:sp>
       <p:sp>
         <p:nvSpPr>
@@ -8648,7 +8864,7 @@
           <a:bodyPr wrap="square" rtlCol="0" anchor="ctr"/>
           <a:lstStyle/>
           <a:p>
-            <a:pPr indent="0" marL="0">
+            <a:pPr marL="0" indent="0">
               <a:buNone/>
             </a:pPr>
             <a:r>
@@ -8687,7 +8903,7 @@
           <a:bodyPr wrap="square" rtlCol="0" anchor="ctr"/>
           <a:lstStyle/>
           <a:p>
-            <a:pPr indent="0" marL="0">
+            <a:pPr marL="0" indent="0">
               <a:buNone/>
             </a:pPr>
             <a:r>
@@ -8726,7 +8942,7 @@
           <a:bodyPr wrap="square" rtlCol="0" anchor="ctr"/>
           <a:lstStyle/>
           <a:p>
-            <a:pPr algn="l" indent="0" marL="0">
+            <a:pPr marL="0" indent="0" algn="l">
               <a:buNone/>
             </a:pPr>
             <a:r>
@@ -8765,7 +8981,7 @@
           <a:bodyPr wrap="square" rtlCol="0" anchor="ctr"/>
           <a:lstStyle/>
           <a:p>
-            <a:pPr algn="r" indent="0" marL="0">
+            <a:pPr marL="0" indent="0" algn="r">
               <a:buNone/>
             </a:pPr>
             <a:r>
@@ -8799,6 +9015,7 @@
         <a:solidFill>
           <a:srgbClr val="F2F1ED"/>
         </a:solidFill>
+        <a:effectLst/>
       </p:bgPr>
     </p:bg>
     <p:spTree>
@@ -8834,6 +9051,13 @@
           </a:solidFill>
           <a:ln/>
         </p:spPr>
+        <p:txBody>
+          <a:bodyPr/>
+          <a:lstStyle/>
+          <a:p>
+            <a:endParaRPr lang="en-US"/>
+          </a:p>
+        </p:txBody>
       </p:sp>
       <p:sp>
         <p:nvSpPr>
@@ -8856,11 +9080,11 @@
           <a:bodyPr wrap="square" rtlCol="0" anchor="ctr"/>
           <a:lstStyle/>
           <a:p>
-            <a:pPr indent="0" marL="0">
-              <a:buNone/>
-            </a:pPr>
-            <a:r>
-              <a:rPr lang="en-US" sz="1100" b="1" spc="600" kern="0" dirty="0">
+            <a:pPr marL="0" indent="0">
+              <a:buNone/>
+            </a:pPr>
+            <a:r>
+              <a:rPr lang="en-US" sz="1100" b="1" kern="0" spc="600" dirty="0">
                 <a:solidFill>
                   <a:srgbClr val="A88147"/>
                 </a:solidFill>
@@ -8895,7 +9119,7 @@
           <a:bodyPr wrap="square" rtlCol="0" anchor="ctr"/>
           <a:lstStyle/>
           <a:p>
-            <a:pPr indent="0" marL="0">
+            <a:pPr marL="0" indent="0">
               <a:buNone/>
             </a:pPr>
             <a:r>
@@ -8937,6 +9161,13 @@
             <a:prstDash val="solid"/>
           </a:ln>
         </p:spPr>
+        <p:txBody>
+          <a:bodyPr/>
+          <a:lstStyle/>
+          <a:p>
+            <a:endParaRPr lang="en-US"/>
+          </a:p>
+        </p:txBody>
       </p:sp>
       <p:sp>
         <p:nvSpPr>
@@ -8959,7 +9190,7 @@
           <a:bodyPr wrap="square" rtlCol="0" anchor="ctr"/>
           <a:lstStyle/>
           <a:p>
-            <a:pPr indent="0" marL="0">
+            <a:pPr marL="0" indent="0">
               <a:buNone/>
             </a:pPr>
             <a:r>
@@ -8998,7 +9229,7 @@
           <a:bodyPr wrap="square" rtlCol="0" anchor="ctr"/>
           <a:lstStyle/>
           <a:p>
-            <a:pPr indent="0" marL="0">
+            <a:pPr marL="0" indent="0">
               <a:buNone/>
             </a:pPr>
             <a:r>
@@ -9037,7 +9268,7 @@
           <a:bodyPr wrap="square" rtlCol="0" anchor="ctr"/>
           <a:lstStyle/>
           <a:p>
-            <a:pPr indent="0" marL="0">
+            <a:pPr marL="0" indent="0">
               <a:buNone/>
             </a:pPr>
             <a:r>
@@ -9079,6 +9310,13 @@
             <a:prstDash val="solid"/>
           </a:ln>
         </p:spPr>
+        <p:txBody>
+          <a:bodyPr/>
+          <a:lstStyle/>
+          <a:p>
+            <a:endParaRPr lang="en-US"/>
+          </a:p>
+        </p:txBody>
       </p:sp>
       <p:sp>
         <p:nvSpPr>
@@ -9101,7 +9339,7 @@
           <a:bodyPr wrap="square" rtlCol="0" anchor="ctr"/>
           <a:lstStyle/>
           <a:p>
-            <a:pPr indent="0" marL="0">
+            <a:pPr marL="0" indent="0">
               <a:buNone/>
             </a:pPr>
             <a:r>
@@ -9140,7 +9378,7 @@
           <a:bodyPr wrap="square" rtlCol="0" anchor="ctr"/>
           <a:lstStyle/>
           <a:p>
-            <a:pPr indent="0" marL="0">
+            <a:pPr marL="0" indent="0">
               <a:buNone/>
             </a:pPr>
             <a:r>
@@ -9179,7 +9417,7 @@
           <a:bodyPr wrap="square" rtlCol="0" anchor="ctr"/>
           <a:lstStyle/>
           <a:p>
-            <a:pPr indent="0" marL="0">
+            <a:pPr marL="0" indent="0">
               <a:buNone/>
             </a:pPr>
             <a:r>
@@ -9221,6 +9459,13 @@
             <a:prstDash val="solid"/>
           </a:ln>
         </p:spPr>
+        <p:txBody>
+          <a:bodyPr/>
+          <a:lstStyle/>
+          <a:p>
+            <a:endParaRPr lang="en-US"/>
+          </a:p>
+        </p:txBody>
       </p:sp>
       <p:sp>
         <p:nvSpPr>
@@ -9243,7 +9488,7 @@
           <a:bodyPr wrap="square" rtlCol="0" anchor="ctr"/>
           <a:lstStyle/>
           <a:p>
-            <a:pPr indent="0" marL="0">
+            <a:pPr marL="0" indent="0">
               <a:buNone/>
             </a:pPr>
             <a:r>
@@ -9282,7 +9527,7 @@
           <a:bodyPr wrap="square" rtlCol="0" anchor="ctr"/>
           <a:lstStyle/>
           <a:p>
-            <a:pPr indent="0" marL="0">
+            <a:pPr marL="0" indent="0">
               <a:buNone/>
             </a:pPr>
             <a:r>
@@ -9321,7 +9566,7 @@
           <a:bodyPr wrap="square" rtlCol="0" anchor="ctr"/>
           <a:lstStyle/>
           <a:p>
-            <a:pPr indent="0" marL="0">
+            <a:pPr marL="0" indent="0">
               <a:buNone/>
             </a:pPr>
             <a:r>
@@ -9363,6 +9608,13 @@
             <a:prstDash val="solid"/>
           </a:ln>
         </p:spPr>
+        <p:txBody>
+          <a:bodyPr/>
+          <a:lstStyle/>
+          <a:p>
+            <a:endParaRPr lang="en-US"/>
+          </a:p>
+        </p:txBody>
       </p:sp>
       <p:sp>
         <p:nvSpPr>
@@ -9385,7 +9637,7 @@
           <a:bodyPr wrap="square" rtlCol="0" anchor="ctr"/>
           <a:lstStyle/>
           <a:p>
-            <a:pPr indent="0" marL="0">
+            <a:pPr marL="0" indent="0">
               <a:buNone/>
             </a:pPr>
             <a:r>
@@ -9424,7 +9676,7 @@
           <a:bodyPr wrap="square" rtlCol="0" anchor="ctr"/>
           <a:lstStyle/>
           <a:p>
-            <a:pPr indent="0" marL="0">
+            <a:pPr marL="0" indent="0">
               <a:buNone/>
             </a:pPr>
             <a:r>
@@ -9463,7 +9715,7 @@
           <a:bodyPr wrap="square" rtlCol="0" anchor="ctr"/>
           <a:lstStyle/>
           <a:p>
-            <a:pPr indent="0" marL="0">
+            <a:pPr marL="0" indent="0">
               <a:buNone/>
             </a:pPr>
             <a:r>
@@ -9502,7 +9754,7 @@
           <a:bodyPr wrap="square" rtlCol="0" anchor="ctr"/>
           <a:lstStyle/>
           <a:p>
-            <a:pPr algn="l" indent="0" marL="0">
+            <a:pPr marL="0" indent="0" algn="l">
               <a:buNone/>
             </a:pPr>
             <a:r>
@@ -9541,7 +9793,7 @@
           <a:bodyPr wrap="square" rtlCol="0" anchor="ctr"/>
           <a:lstStyle/>
           <a:p>
-            <a:pPr algn="r" indent="0" marL="0">
+            <a:pPr marL="0" indent="0" algn="r">
               <a:buNone/>
             </a:pPr>
             <a:r>
@@ -9860,4 +10112,319 @@
     </a:ext>
   </a:extLst>
 </a:theme>
+</file>
+
+<file path=ppt/theme/theme2.xml><?xml version="1.0" encoding="utf-8"?>
+<a:theme xmlns:a="http://schemas.openxmlformats.org/drawingml/2006/main" name="Office Theme">
+  <a:themeElements>
+    <a:clrScheme name="Office">
+      <a:dk1>
+        <a:sysClr val="windowText" lastClr="000000"/>
+      </a:dk1>
+      <a:lt1>
+        <a:sysClr val="window" lastClr="FFFFFF"/>
+      </a:lt1>
+      <a:dk2>
+        <a:srgbClr val="0E2841"/>
+      </a:dk2>
+      <a:lt2>
+        <a:srgbClr val="E8E8E8"/>
+      </a:lt2>
+      <a:accent1>
+        <a:srgbClr val="156082"/>
+      </a:accent1>
+      <a:accent2>
+        <a:srgbClr val="E97132"/>
+      </a:accent2>
+      <a:accent3>
+        <a:srgbClr val="196B24"/>
+      </a:accent3>
+      <a:accent4>
+        <a:srgbClr val="0F9ED5"/>
+      </a:accent4>
+      <a:accent5>
+        <a:srgbClr val="A02B93"/>
+      </a:accent5>
+      <a:accent6>
+        <a:srgbClr val="4EA72E"/>
+      </a:accent6>
+      <a:hlink>
+        <a:srgbClr val="467886"/>
+      </a:hlink>
+      <a:folHlink>
+        <a:srgbClr val="96607D"/>
+      </a:folHlink>
+    </a:clrScheme>
+    <a:fontScheme name="Office">
+      <a:majorFont>
+        <a:latin typeface="Aptos Display" panose="02110004020202020204"/>
+        <a:ea typeface=""/>
+        <a:cs typeface=""/>
+        <a:font script="Jpan" typeface="游ゴシック Light"/>
+        <a:font script="Hang" typeface="맑은 고딕"/>
+        <a:font script="Hans" typeface="等线 Light"/>
+        <a:font script="Hant" typeface="新細明體"/>
+        <a:font script="Arab" typeface="Times New Roman"/>
+        <a:font script="Hebr" typeface="Times New Roman"/>
+        <a:font script="Thai" typeface="Angsana New"/>
+        <a:font script="Ethi" typeface="Nyala"/>
+        <a:font script="Beng" typeface="Vrinda"/>
+        <a:font script="Gujr" typeface="Shruti"/>
+        <a:font script="Khmr" typeface="MoolBoran"/>
+        <a:font script="Knda" typeface="Tunga"/>
+        <a:font script="Guru" typeface="Raavi"/>
+        <a:font script="Cans" typeface="Euphemia"/>
+        <a:font script="Cher" typeface="Plantagenet Cherokee"/>
+        <a:font script="Yiii" typeface="Microsoft Yi Baiti"/>
+        <a:font script="Tibt" typeface="Microsoft Himalaya"/>
+        <a:font script="Thaa" typeface="MV Boli"/>
+        <a:font script="Deva" typeface="Mangal"/>
+        <a:font script="Telu" typeface="Gautami"/>
+        <a:font script="Taml" typeface="Latha"/>
+        <a:font script="Syrc" typeface="Estrangelo Edessa"/>
+        <a:font script="Orya" typeface="Kalinga"/>
+        <a:font script="Mlym" typeface="Kartika"/>
+        <a:font script="Laoo" typeface="DokChampa"/>
+        <a:font script="Sinh" typeface="Iskoola Pota"/>
+        <a:font script="Mong" typeface="Mongolian Baiti"/>
+        <a:font script="Viet" typeface="Times New Roman"/>
+        <a:font script="Uigh" typeface="Microsoft Uighur"/>
+        <a:font script="Geor" typeface="Sylfaen"/>
+        <a:font script="Armn" typeface="Arial"/>
+        <a:font script="Bugi" typeface="Leelawadee UI"/>
+        <a:font script="Bopo" typeface="Microsoft JhengHei"/>
+        <a:font script="Java" typeface="Javanese Text"/>
+        <a:font script="Lisu" typeface="Segoe UI"/>
+        <a:font script="Mymr" typeface="Myanmar Text"/>
+        <a:font script="Nkoo" typeface="Ebrima"/>
+        <a:font script="Olck" typeface="Nirmala UI"/>
+        <a:font script="Osma" typeface="Ebrima"/>
+        <a:font script="Phag" typeface="Phagspa"/>
+        <a:font script="Syrn" typeface="Estrangelo Edessa"/>
+        <a:font script="Syrj" typeface="Estrangelo Edessa"/>
+        <a:font script="Syre" typeface="Estrangelo Edessa"/>
+        <a:font script="Sora" typeface="Nirmala UI"/>
+        <a:font script="Tale" typeface="Microsoft Tai Le"/>
+        <a:font script="Talu" typeface="Microsoft New Tai Lue"/>
+        <a:font script="Tfng" typeface="Ebrima"/>
+      </a:majorFont>
+      <a:minorFont>
+        <a:latin typeface="Aptos" panose="02110004020202020204"/>
+        <a:ea typeface=""/>
+        <a:cs typeface=""/>
+        <a:font script="Jpan" typeface="游ゴシック"/>
+        <a:font script="Hang" typeface="맑은 고딕"/>
+        <a:font script="Hans" typeface="等线"/>
+        <a:font script="Hant" typeface="新細明體"/>
+        <a:font script="Arab" typeface="Arial"/>
+        <a:font script="Hebr" typeface="Arial"/>
+        <a:font script="Thai" typeface="Cordia New"/>
+        <a:font script="Ethi" typeface="Nyala"/>
+        <a:font script="Beng" typeface="Vrinda"/>
+        <a:font script="Gujr" typeface="Shruti"/>
+        <a:font script="Khmr" typeface="DaunPenh"/>
+        <a:font script="Knda" typeface="Tunga"/>
+        <a:font script="Guru" typeface="Raavi"/>
+        <a:font script="Cans" typeface="Euphemia"/>
+        <a:font script="Cher" typeface="Plantagenet Cherokee"/>
+        <a:font script="Yiii" typeface="Microsoft Yi Baiti"/>
+        <a:font script="Tibt" typeface="Microsoft Himalaya"/>
+        <a:font script="Thaa" typeface="MV Boli"/>
+        <a:font script="Deva" typeface="Mangal"/>
+        <a:font script="Telu" typeface="Gautami"/>
+        <a:font script="Taml" typeface="Latha"/>
+        <a:font script="Syrc" typeface="Estrangelo Edessa"/>
+        <a:font script="Orya" typeface="Kalinga"/>
+        <a:font script="Mlym" typeface="Kartika"/>
+        <a:font script="Laoo" typeface="DokChampa"/>
+        <a:font script="Sinh" typeface="Iskoola Pota"/>
+        <a:font script="Mong" typeface="Mongolian Baiti"/>
+        <a:font script="Viet" typeface="Arial"/>
+        <a:font script="Uigh" typeface="Microsoft Uighur"/>
+        <a:font script="Geor" typeface="Sylfaen"/>
+        <a:font script="Armn" typeface="Arial"/>
+        <a:font script="Bugi" typeface="Leelawadee UI"/>
+        <a:font script="Bopo" typeface="Microsoft JhengHei"/>
+        <a:font script="Java" typeface="Javanese Text"/>
+        <a:font script="Lisu" typeface="Segoe UI"/>
+        <a:font script="Mymr" typeface="Myanmar Text"/>
+        <a:font script="Nkoo" typeface="Ebrima"/>
+        <a:font script="Olck" typeface="Nirmala UI"/>
+        <a:font script="Osma" typeface="Ebrima"/>
+        <a:font script="Phag" typeface="Phagspa"/>
+        <a:font script="Syrn" typeface="Estrangelo Edessa"/>
+        <a:font script="Syrj" typeface="Estrangelo Edessa"/>
+        <a:font script="Syre" typeface="Estrangelo Edessa"/>
+        <a:font script="Sora" typeface="Nirmala UI"/>
+        <a:font script="Tale" typeface="Microsoft Tai Le"/>
+        <a:font script="Talu" typeface="Microsoft New Tai Lue"/>
+        <a:font script="Tfng" typeface="Ebrima"/>
+      </a:minorFont>
+    </a:fontScheme>
+    <a:fmtScheme name="Office">
+      <a:fillStyleLst>
+        <a:solidFill>
+          <a:schemeClr val="phClr"/>
+        </a:solidFill>
+        <a:gradFill rotWithShape="1">
+          <a:gsLst>
+            <a:gs pos="0">
+              <a:schemeClr val="phClr">
+                <a:lumMod val="110000"/>
+                <a:satMod val="105000"/>
+                <a:tint val="67000"/>
+              </a:schemeClr>
+            </a:gs>
+            <a:gs pos="50000">
+              <a:schemeClr val="phClr">
+                <a:lumMod val="105000"/>
+                <a:satMod val="103000"/>
+                <a:tint val="73000"/>
+              </a:schemeClr>
+            </a:gs>
+            <a:gs pos="100000">
+              <a:schemeClr val="phClr">
+                <a:lumMod val="105000"/>
+                <a:satMod val="109000"/>
+                <a:tint val="81000"/>
+              </a:schemeClr>
+            </a:gs>
+          </a:gsLst>
+          <a:lin ang="5400000" scaled="0"/>
+        </a:gradFill>
+        <a:gradFill rotWithShape="1">
+          <a:gsLst>
+            <a:gs pos="0">
+              <a:schemeClr val="phClr">
+                <a:satMod val="103000"/>
+                <a:lumMod val="102000"/>
+                <a:tint val="94000"/>
+              </a:schemeClr>
+            </a:gs>
+            <a:gs pos="50000">
+              <a:schemeClr val="phClr">
+                <a:satMod val="110000"/>
+                <a:lumMod val="100000"/>
+                <a:shade val="100000"/>
+              </a:schemeClr>
+            </a:gs>
+            <a:gs pos="100000">
+              <a:schemeClr val="phClr">
+                <a:lumMod val="99000"/>
+                <a:satMod val="120000"/>
+                <a:shade val="78000"/>
+              </a:schemeClr>
+            </a:gs>
+          </a:gsLst>
+          <a:lin ang="5400000" scaled="0"/>
+        </a:gradFill>
+      </a:fillStyleLst>
+      <a:lnStyleLst>
+        <a:ln w="12700" cap="flat" cmpd="sng" algn="ctr">
+          <a:solidFill>
+            <a:schemeClr val="phClr"/>
+          </a:solidFill>
+          <a:prstDash val="solid"/>
+          <a:miter lim="800000"/>
+        </a:ln>
+        <a:ln w="19050" cap="flat" cmpd="sng" algn="ctr">
+          <a:solidFill>
+            <a:schemeClr val="phClr"/>
+          </a:solidFill>
+          <a:prstDash val="solid"/>
+          <a:miter lim="800000"/>
+        </a:ln>
+        <a:ln w="25400" cap="flat" cmpd="sng" algn="ctr">
+          <a:solidFill>
+            <a:schemeClr val="phClr"/>
+          </a:solidFill>
+          <a:prstDash val="solid"/>
+          <a:miter lim="800000"/>
+        </a:ln>
+      </a:lnStyleLst>
+      <a:effectStyleLst>
+        <a:effectStyle>
+          <a:effectLst/>
+        </a:effectStyle>
+        <a:effectStyle>
+          <a:effectLst/>
+        </a:effectStyle>
+        <a:effectStyle>
+          <a:effectLst>
+            <a:outerShdw blurRad="57150" dist="19050" dir="5400000" algn="ctr" rotWithShape="0">
+              <a:srgbClr val="000000">
+                <a:alpha val="63000"/>
+              </a:srgbClr>
+            </a:outerShdw>
+          </a:effectLst>
+        </a:effectStyle>
+      </a:effectStyleLst>
+      <a:bgFillStyleLst>
+        <a:solidFill>
+          <a:schemeClr val="phClr"/>
+        </a:solidFill>
+        <a:solidFill>
+          <a:schemeClr val="phClr">
+            <a:tint val="95000"/>
+            <a:satMod val="170000"/>
+          </a:schemeClr>
+        </a:solidFill>
+        <a:gradFill rotWithShape="1">
+          <a:gsLst>
+            <a:gs pos="0">
+              <a:schemeClr val="phClr">
+                <a:tint val="93000"/>
+                <a:satMod val="150000"/>
+                <a:shade val="98000"/>
+                <a:lumMod val="102000"/>
+              </a:schemeClr>
+            </a:gs>
+            <a:gs pos="50000">
+              <a:schemeClr val="phClr">
+                <a:tint val="98000"/>
+                <a:satMod val="130000"/>
+                <a:shade val="90000"/>
+                <a:lumMod val="103000"/>
+              </a:schemeClr>
+            </a:gs>
+            <a:gs pos="100000">
+              <a:schemeClr val="phClr">
+                <a:shade val="63000"/>
+                <a:satMod val="120000"/>
+              </a:schemeClr>
+            </a:gs>
+          </a:gsLst>
+          <a:lin ang="5400000" scaled="0"/>
+        </a:gradFill>
+      </a:bgFillStyleLst>
+    </a:fmtScheme>
+  </a:themeElements>
+  <a:objectDefaults>
+    <a:lnDef>
+      <a:spPr/>
+      <a:bodyPr/>
+      <a:lstStyle/>
+      <a:style>
+        <a:lnRef idx="2">
+          <a:schemeClr val="accent1"/>
+        </a:lnRef>
+        <a:fillRef idx="0">
+          <a:schemeClr val="accent1"/>
+        </a:fillRef>
+        <a:effectRef idx="1">
+          <a:schemeClr val="accent1"/>
+        </a:effectRef>
+        <a:fontRef idx="minor">
+          <a:schemeClr val="tx1"/>
+        </a:fontRef>
+      </a:style>
+    </a:lnDef>
+  </a:objectDefaults>
+  <a:extraClrSchemeLst/>
+  <a:extLst>
+    <a:ext uri="{05A4C25C-085E-4340-85A3-A5531E510DB2}">
+      <thm15:themeFamily xmlns:thm15="http://schemas.microsoft.com/office/thememl/2012/main" name="Office Theme" id="{2E142A2C-CD16-42D6-873A-C26D2A0506FA}" vid="{1BDDFF52-6CD6-40A5-AB3C-68EB2F1E4D0A}"/>
+    </a:ext>
+  </a:extLst>
+</a:theme>
 </file>
</xml_diff>